<commit_message>
Enhance presentation slide deck design layout and aesthetics
</commit_message>
<xml_diff>
--- a/docs/NyayaAI_Project_Presentation.pptx
+++ b/docs/NyayaAI_Project_Presentation.pptx
@@ -3103,7 +3103,93 @@
         <p:spPr>
           <a:xfrm>
             <a:off x="0" y="0"/>
-            <a:ext cx="12191695" cy="6858000"/>
+            <a:ext cx="4114800" cy="6858000"/>
+          </a:xfrm>
+          <a:prstGeom prst="rect">
+            <a:avLst/>
+          </a:prstGeom>
+          <a:solidFill>
+            <a:srgbClr val="102C57"/>
+          </a:solidFill>
+          <a:ln>
+            <a:noFill/>
+          </a:ln>
+        </p:spPr>
+        <p:style>
+          <a:lnRef idx="1">
+            <a:schemeClr val="accent1"/>
+          </a:lnRef>
+          <a:fillRef idx="3">
+            <a:schemeClr val="accent1"/>
+          </a:fillRef>
+          <a:effectRef idx="2">
+            <a:schemeClr val="accent1"/>
+          </a:effectRef>
+          <a:fontRef idx="minor">
+            <a:schemeClr val="lt1"/>
+          </a:fontRef>
+        </p:style>
+        <p:txBody>
+          <a:bodyPr rtlCol="0" anchor="ctr"/>
+          <a:lstStyle/>
+          <a:p>
+            <a:pPr algn="ctr"/>
+          </a:p>
+        </p:txBody>
+      </p:sp>
+      <p:sp>
+        <p:nvSpPr>
+          <p:cNvPr id="3" name="Rectangle 2"/>
+          <p:cNvSpPr/>
+          <p:nvPr/>
+        </p:nvSpPr>
+        <p:spPr>
+          <a:xfrm>
+            <a:off x="4114800" y="0"/>
+            <a:ext cx="73152" cy="6858000"/>
+          </a:xfrm>
+          <a:prstGeom prst="rect">
+            <a:avLst/>
+          </a:prstGeom>
+          <a:solidFill>
+            <a:srgbClr val="B48C28"/>
+          </a:solidFill>
+          <a:ln>
+            <a:noFill/>
+          </a:ln>
+        </p:spPr>
+        <p:style>
+          <a:lnRef idx="1">
+            <a:schemeClr val="accent1"/>
+          </a:lnRef>
+          <a:fillRef idx="3">
+            <a:schemeClr val="accent1"/>
+          </a:fillRef>
+          <a:effectRef idx="2">
+            <a:schemeClr val="accent1"/>
+          </a:effectRef>
+          <a:fontRef idx="minor">
+            <a:schemeClr val="lt1"/>
+          </a:fontRef>
+        </p:style>
+        <p:txBody>
+          <a:bodyPr rtlCol="0" anchor="ctr"/>
+          <a:lstStyle/>
+          <a:p>
+            <a:pPr algn="ctr"/>
+          </a:p>
+        </p:txBody>
+      </p:sp>
+      <p:sp>
+        <p:nvSpPr>
+          <p:cNvPr id="4" name="Rectangle 3"/>
+          <p:cNvSpPr/>
+          <p:nvPr/>
+        </p:nvSpPr>
+        <p:spPr>
+          <a:xfrm>
+            <a:off x="4187952" y="0"/>
+            <a:ext cx="8001000" cy="6858000"/>
           </a:xfrm>
           <a:prstGeom prst="rect">
             <a:avLst/>
@@ -3139,57 +3225,14 @@
       </p:sp>
       <p:sp>
         <p:nvSpPr>
-          <p:cNvPr id="3" name="Rectangle 2"/>
-          <p:cNvSpPr/>
-          <p:nvPr/>
-        </p:nvSpPr>
-        <p:spPr>
-          <a:xfrm>
-            <a:off x="0" y="0"/>
-            <a:ext cx="365760" cy="6858000"/>
-          </a:xfrm>
-          <a:prstGeom prst="rect">
-            <a:avLst/>
-          </a:prstGeom>
-          <a:solidFill>
-            <a:srgbClr val="102C57"/>
-          </a:solidFill>
-          <a:ln>
-            <a:noFill/>
-          </a:ln>
-        </p:spPr>
-        <p:style>
-          <a:lnRef idx="1">
-            <a:schemeClr val="accent1"/>
-          </a:lnRef>
-          <a:fillRef idx="3">
-            <a:schemeClr val="accent1"/>
-          </a:fillRef>
-          <a:effectRef idx="2">
-            <a:schemeClr val="accent1"/>
-          </a:effectRef>
-          <a:fontRef idx="minor">
-            <a:schemeClr val="lt1"/>
-          </a:fontRef>
-        </p:style>
-        <p:txBody>
-          <a:bodyPr rtlCol="0" anchor="ctr"/>
-          <a:lstStyle/>
-          <a:p>
-            <a:pPr algn="ctr"/>
-          </a:p>
-        </p:txBody>
-      </p:sp>
-      <p:sp>
-        <p:nvSpPr>
-          <p:cNvPr id="4" name="TextBox 3"/>
+          <p:cNvPr id="5" name="TextBox 4"/>
           <p:cNvSpPr txBox="1"/>
           <p:nvPr/>
         </p:nvSpPr>
         <p:spPr>
           <a:xfrm>
-            <a:off x="1097280" y="1645920"/>
-            <a:ext cx="10058400" cy="2011680"/>
+            <a:off x="457200" y="2011680"/>
+            <a:ext cx="3200400" cy="3200400"/>
           </a:xfrm>
           <a:prstGeom prst="rect">
             <a:avLst/>
@@ -3203,9 +3246,9 @@
           <a:lstStyle/>
           <a:p>
             <a:pPr>
-              <a:defRPr sz="6400" b="1">
-                <a:solidFill>
-                  <a:srgbClr val="102C57"/>
+              <a:defRPr sz="5600" b="1">
+                <a:solidFill>
+                  <a:srgbClr val="B48C28"/>
                 </a:solidFill>
                 <a:latin typeface="Georgia"/>
               </a:defRPr>
@@ -3217,31 +3260,31 @@
           <a:p>
             <a:pPr>
               <a:spcBef>
-                <a:spcPts val="1000"/>
+                <a:spcPts val="1200"/>
               </a:spcBef>
-              <a:defRPr sz="2800" b="1">
-                <a:solidFill>
-                  <a:srgbClr val="B48C28"/>
+              <a:defRPr sz="1800">
+                <a:solidFill>
+                  <a:srgbClr val="FFFFFF"/>
                 </a:solidFill>
                 <a:latin typeface="Arial"/>
               </a:defRPr>
             </a:pPr>
             <a:r>
-              <a:t>AI-Powered Legal Case Analysis and Outcome Prediction System</a:t>
-            </a:r>
-          </a:p>
-        </p:txBody>
-      </p:sp>
-      <p:sp>
-        <p:nvSpPr>
-          <p:cNvPr id="5" name="TextBox 4"/>
+              <a:t>AI Legal Precedent Analysis</a:t>
+            </a:r>
+          </a:p>
+        </p:txBody>
+      </p:sp>
+      <p:sp>
+        <p:nvSpPr>
+          <p:cNvPr id="6" name="TextBox 5"/>
           <p:cNvSpPr txBox="1"/>
           <p:nvPr/>
         </p:nvSpPr>
         <p:spPr>
           <a:xfrm>
-            <a:off x="1097280" y="4114800"/>
-            <a:ext cx="10058400" cy="1828800"/>
+            <a:off x="4754880" y="2011680"/>
+            <a:ext cx="6858000" cy="3657600"/>
           </a:xfrm>
           <a:prstGeom prst="rect">
             <a:avLst/>
@@ -3249,15 +3292,31 @@
           <a:noFill/>
         </p:spPr>
         <p:txBody>
-          <a:bodyPr wrap="none">
+          <a:bodyPr wrap="square">
             <a:spAutoFit/>
           </a:bodyPr>
           <a:lstStyle/>
           <a:p>
             <a:pPr>
+              <a:spcAft>
+                <a:spcPts val="2000"/>
+              </a:spcAft>
+              <a:defRPr sz="3600" b="1">
+                <a:solidFill>
+                  <a:srgbClr val="102C57"/>
+                </a:solidFill>
+                <a:latin typeface="Georgia"/>
+              </a:defRPr>
+            </a:pPr>
+            <a:r>
+              <a:t>AI-Powered Legal Case Analysis &amp; Outcome Prediction System</a:t>
+            </a:r>
+          </a:p>
+          <a:p>
+            <a:pPr>
               <a:defRPr sz="1800">
                 <a:solidFill>
-                  <a:srgbClr val="323232"/>
+                  <a:srgbClr val="282828"/>
                 </a:solidFill>
                 <a:latin typeface="Arial"/>
               </a:defRPr>
@@ -3267,7 +3326,7 @@
             </a:r>
             <a:br/>
             <a:r>
-              <a:t>Indian Legal Domain Framework</a:t>
+              <a:t>Indian Judicial Analytics Framework</a:t>
             </a:r>
           </a:p>
         </p:txBody>
@@ -3292,14 +3351,57 @@
       <p:grpSpPr/>
       <p:sp>
         <p:nvSpPr>
-          <p:cNvPr id="2" name="TextBox 1"/>
+          <p:cNvPr id="2" name="Rectangle 1"/>
+          <p:cNvSpPr/>
+          <p:nvPr/>
+        </p:nvSpPr>
+        <p:spPr>
+          <a:xfrm>
+            <a:off x="0" y="0"/>
+            <a:ext cx="12191695" cy="6858000"/>
+          </a:xfrm>
+          <a:prstGeom prst="rect">
+            <a:avLst/>
+          </a:prstGeom>
+          <a:solidFill>
+            <a:srgbClr val="F5F7FA"/>
+          </a:solidFill>
+          <a:ln>
+            <a:noFill/>
+          </a:ln>
+        </p:spPr>
+        <p:style>
+          <a:lnRef idx="1">
+            <a:schemeClr val="accent1"/>
+          </a:lnRef>
+          <a:fillRef idx="3">
+            <a:schemeClr val="accent1"/>
+          </a:fillRef>
+          <a:effectRef idx="2">
+            <a:schemeClr val="accent1"/>
+          </a:effectRef>
+          <a:fontRef idx="minor">
+            <a:schemeClr val="lt1"/>
+          </a:fontRef>
+        </p:style>
+        <p:txBody>
+          <a:bodyPr rtlCol="0" anchor="ctr"/>
+          <a:lstStyle/>
+          <a:p>
+            <a:pPr algn="ctr"/>
+          </a:p>
+        </p:txBody>
+      </p:sp>
+      <p:sp>
+        <p:nvSpPr>
+          <p:cNvPr id="3" name="TextBox 2"/>
           <p:cNvSpPr txBox="1"/>
           <p:nvPr/>
         </p:nvSpPr>
         <p:spPr>
           <a:xfrm>
             <a:off x="685800" y="365760"/>
-            <a:ext cx="10789920" cy="914400"/>
+            <a:ext cx="10817352" cy="731520"/>
           </a:xfrm>
           <a:prstGeom prst="rect">
             <a:avLst/>
@@ -3313,7 +3415,7 @@
           <a:lstStyle/>
           <a:p>
             <a:pPr>
-              <a:defRPr sz="3600" b="1">
+              <a:defRPr sz="3200" b="1">
                 <a:solidFill>
                   <a:srgbClr val="102C57"/>
                 </a:solidFill>
@@ -3328,14 +3430,14 @@
       </p:sp>
       <p:sp>
         <p:nvSpPr>
-          <p:cNvPr id="3" name="Rectangle 2"/>
+          <p:cNvPr id="4" name="Rectangle 3"/>
           <p:cNvSpPr/>
           <p:nvPr/>
         </p:nvSpPr>
         <p:spPr>
           <a:xfrm>
-            <a:off x="685800" y="1097280"/>
-            <a:ext cx="10817352" cy="36576"/>
+            <a:off x="685800" y="1051560"/>
+            <a:ext cx="1371600" cy="45720"/>
           </a:xfrm>
           <a:prstGeom prst="rect">
             <a:avLst/>
@@ -3371,14 +3473,59 @@
       </p:sp>
       <p:sp>
         <p:nvSpPr>
-          <p:cNvPr id="4" name="TextBox 3"/>
+          <p:cNvPr id="5" name="Rounded Rectangle 4"/>
+          <p:cNvSpPr/>
+          <p:nvPr/>
+        </p:nvSpPr>
+        <p:spPr>
+          <a:xfrm>
+            <a:off x="685800" y="1463040"/>
+            <a:ext cx="5303520" cy="2103120"/>
+          </a:xfrm>
+          <a:prstGeom prst="roundRect">
+            <a:avLst/>
+          </a:prstGeom>
+          <a:solidFill>
+            <a:srgbClr val="FFFFFF"/>
+          </a:solidFill>
+          <a:ln w="12700">
+            <a:solidFill>
+              <a:srgbClr val="DAE0E9"/>
+            </a:solidFill>
+          </a:ln>
+        </p:spPr>
+        <p:style>
+          <a:lnRef idx="1">
+            <a:schemeClr val="accent1"/>
+          </a:lnRef>
+          <a:fillRef idx="3">
+            <a:schemeClr val="accent1"/>
+          </a:fillRef>
+          <a:effectRef idx="2">
+            <a:schemeClr val="accent1"/>
+          </a:effectRef>
+          <a:fontRef idx="minor">
+            <a:schemeClr val="lt1"/>
+          </a:fontRef>
+        </p:style>
+        <p:txBody>
+          <a:bodyPr rtlCol="0" anchor="ctr"/>
+          <a:lstStyle/>
+          <a:p>
+            <a:pPr algn="ctr"/>
+          </a:p>
+        </p:txBody>
+      </p:sp>
+      <p:sp>
+        <p:nvSpPr>
+          <p:cNvPr id="6" name="TextBox 5"/>
           <p:cNvSpPr txBox="1"/>
           <p:nvPr/>
         </p:nvSpPr>
         <p:spPr>
           <a:xfrm>
-            <a:off x="685800" y="1463040"/>
-            <a:ext cx="10817352" cy="4572000"/>
+            <a:off x="868680" y="1600200"/>
+            <a:ext cx="914400" cy="457200"/>
           </a:xfrm>
           <a:prstGeom prst="rect">
             <a:avLst/>
@@ -3386,149 +3533,472 @@
           <a:noFill/>
         </p:spPr>
         <p:txBody>
+          <a:bodyPr wrap="none">
+            <a:spAutoFit/>
+          </a:bodyPr>
+          <a:lstStyle/>
+          <a:p>
+            <a:pPr>
+              <a:defRPr sz="2400" b="1">
+                <a:solidFill>
+                  <a:srgbClr val="B48C28"/>
+                </a:solidFill>
+                <a:latin typeface="Georgia"/>
+              </a:defRPr>
+            </a:pPr>
+            <a:r>
+              <a:t>01</a:t>
+            </a:r>
+          </a:p>
+        </p:txBody>
+      </p:sp>
+      <p:sp>
+        <p:nvSpPr>
+          <p:cNvPr id="7" name="TextBox 6"/>
+          <p:cNvSpPr txBox="1"/>
+          <p:nvPr/>
+        </p:nvSpPr>
+        <p:spPr>
+          <a:xfrm>
+            <a:off x="1600200" y="1600200"/>
+            <a:ext cx="4114800" cy="1828800"/>
+          </a:xfrm>
+          <a:prstGeom prst="rect">
+            <a:avLst/>
+          </a:prstGeom>
+          <a:noFill/>
+        </p:spPr>
+        <p:txBody>
           <a:bodyPr wrap="square">
             <a:spAutoFit/>
           </a:bodyPr>
           <a:lstStyle/>
-          <a:p/>
-          <a:p>
-            <a:pPr>
-              <a:spcBef>
-                <a:spcPts val="800"/>
-              </a:spcBef>
-              <a:spcAft>
-                <a:spcPts val="200"/>
-              </a:spcAft>
-              <a:defRPr b="1" sz="1800">
-                <a:solidFill>
-                  <a:srgbClr val="102C57"/>
-                </a:solidFill>
-                <a:latin typeface="Arial"/>
-              </a:defRPr>
-            </a:pPr>
-            <a:r>
-              <a:t>•  Huge Case Backlogs in Indian Courts: </a:t>
-            </a:r>
-          </a:p>
           <a:p>
             <a:pPr>
               <a:spcAft>
-                <a:spcPts val="1000"/>
+                <a:spcPts val="600"/>
               </a:spcAft>
-              <a:defRPr sz="1500">
-                <a:solidFill>
-                  <a:srgbClr val="323232"/>
+              <a:defRPr sz="1800" b="1">
+                <a:solidFill>
+                  <a:srgbClr val="102C57"/>
                 </a:solidFill>
                 <a:latin typeface="Arial"/>
               </a:defRPr>
             </a:pPr>
             <a:r>
-              <a:t>    Over 4.5 crore (45 million) pending cases create massive systemic delays in the Indian judicial system.</a:t>
+              <a:t>4.5 Crore Pending Cases</a:t>
             </a:r>
           </a:p>
           <a:p>
             <a:pPr>
-              <a:spcBef>
-                <a:spcPts val="800"/>
-              </a:spcBef>
-              <a:spcAft>
-                <a:spcPts val="200"/>
-              </a:spcAft>
-              <a:defRPr b="1" sz="1800">
-                <a:solidFill>
-                  <a:srgbClr val="102C57"/>
+              <a:defRPr sz="1400">
+                <a:solidFill>
+                  <a:srgbClr val="282828"/>
                 </a:solidFill>
                 <a:latin typeface="Arial"/>
               </a:defRPr>
             </a:pPr>
             <a:r>
-              <a:t>•  Information Asymmetry for Common Litigants: </a:t>
-            </a:r>
-          </a:p>
+              <a:t>Indian courts suffer from massive backlogs, causing prolonged litigation delay.</a:t>
+            </a:r>
+          </a:p>
+        </p:txBody>
+      </p:sp>
+      <p:sp>
+        <p:nvSpPr>
+          <p:cNvPr id="8" name="Rounded Rectangle 7"/>
+          <p:cNvSpPr/>
+          <p:nvPr/>
+        </p:nvSpPr>
+        <p:spPr>
+          <a:xfrm>
+            <a:off x="6172200" y="1463040"/>
+            <a:ext cx="5303520" cy="2103120"/>
+          </a:xfrm>
+          <a:prstGeom prst="roundRect">
+            <a:avLst/>
+          </a:prstGeom>
+          <a:solidFill>
+            <a:srgbClr val="FFFFFF"/>
+          </a:solidFill>
+          <a:ln w="12700">
+            <a:solidFill>
+              <a:srgbClr val="DAE0E9"/>
+            </a:solidFill>
+          </a:ln>
+        </p:spPr>
+        <p:style>
+          <a:lnRef idx="1">
+            <a:schemeClr val="accent1"/>
+          </a:lnRef>
+          <a:fillRef idx="3">
+            <a:schemeClr val="accent1"/>
+          </a:fillRef>
+          <a:effectRef idx="2">
+            <a:schemeClr val="accent1"/>
+          </a:effectRef>
+          <a:fontRef idx="minor">
+            <a:schemeClr val="lt1"/>
+          </a:fontRef>
+        </p:style>
+        <p:txBody>
+          <a:bodyPr rtlCol="0" anchor="ctr"/>
+          <a:lstStyle/>
+          <a:p>
+            <a:pPr algn="ctr"/>
+          </a:p>
+        </p:txBody>
+      </p:sp>
+      <p:sp>
+        <p:nvSpPr>
+          <p:cNvPr id="9" name="TextBox 8"/>
+          <p:cNvSpPr txBox="1"/>
+          <p:nvPr/>
+        </p:nvSpPr>
+        <p:spPr>
+          <a:xfrm>
+            <a:off x="6355080" y="1600200"/>
+            <a:ext cx="914400" cy="457200"/>
+          </a:xfrm>
+          <a:prstGeom prst="rect">
+            <a:avLst/>
+          </a:prstGeom>
+          <a:noFill/>
+        </p:spPr>
+        <p:txBody>
+          <a:bodyPr wrap="none">
+            <a:spAutoFit/>
+          </a:bodyPr>
+          <a:lstStyle/>
+          <a:p>
+            <a:pPr>
+              <a:defRPr sz="2400" b="1">
+                <a:solidFill>
+                  <a:srgbClr val="B48C28"/>
+                </a:solidFill>
+                <a:latin typeface="Georgia"/>
+              </a:defRPr>
+            </a:pPr>
+            <a:r>
+              <a:t>02</a:t>
+            </a:r>
+          </a:p>
+        </p:txBody>
+      </p:sp>
+      <p:sp>
+        <p:nvSpPr>
+          <p:cNvPr id="10" name="TextBox 9"/>
+          <p:cNvSpPr txBox="1"/>
+          <p:nvPr/>
+        </p:nvSpPr>
+        <p:spPr>
+          <a:xfrm>
+            <a:off x="7086600" y="1600200"/>
+            <a:ext cx="4114800" cy="1828800"/>
+          </a:xfrm>
+          <a:prstGeom prst="rect">
+            <a:avLst/>
+          </a:prstGeom>
+          <a:noFill/>
+        </p:spPr>
+        <p:txBody>
+          <a:bodyPr wrap="square">
+            <a:spAutoFit/>
+          </a:bodyPr>
+          <a:lstStyle/>
           <a:p>
             <a:pPr>
               <a:spcAft>
-                <a:spcPts val="1000"/>
+                <a:spcPts val="600"/>
               </a:spcAft>
-              <a:defRPr sz="1500">
-                <a:solidFill>
-                  <a:srgbClr val="323232"/>
+              <a:defRPr sz="1800" b="1">
+                <a:solidFill>
+                  <a:srgbClr val="102C57"/>
                 </a:solidFill>
                 <a:latin typeface="Arial"/>
               </a:defRPr>
             </a:pPr>
             <a:r>
-              <a:t>    Citizens lack accessible, affordable platforms to understand the potential strength and merits of their legal grievances.</a:t>
+              <a:t>Information Asymmetry</a:t>
             </a:r>
           </a:p>
           <a:p>
             <a:pPr>
-              <a:spcBef>
-                <a:spcPts val="800"/>
-              </a:spcBef>
-              <a:spcAft>
-                <a:spcPts val="200"/>
-              </a:spcAft>
-              <a:defRPr b="1" sz="1800">
-                <a:solidFill>
-                  <a:srgbClr val="102C57"/>
+              <a:defRPr sz="1400">
+                <a:solidFill>
+                  <a:srgbClr val="282828"/>
                 </a:solidFill>
                 <a:latin typeface="Arial"/>
               </a:defRPr>
             </a:pPr>
             <a:r>
-              <a:t>•  Manual Precedent Research Burden: </a:t>
-            </a:r>
-          </a:p>
+              <a:t>Citizens and small business entities lack affordable analytical tools to evaluate case merit.</a:t>
+            </a:r>
+          </a:p>
+        </p:txBody>
+      </p:sp>
+      <p:sp>
+        <p:nvSpPr>
+          <p:cNvPr id="11" name="Rounded Rectangle 10"/>
+          <p:cNvSpPr/>
+          <p:nvPr/>
+        </p:nvSpPr>
+        <p:spPr>
+          <a:xfrm>
+            <a:off x="685800" y="3931920"/>
+            <a:ext cx="5303520" cy="2103120"/>
+          </a:xfrm>
+          <a:prstGeom prst="roundRect">
+            <a:avLst/>
+          </a:prstGeom>
+          <a:solidFill>
+            <a:srgbClr val="FFFFFF"/>
+          </a:solidFill>
+          <a:ln w="12700">
+            <a:solidFill>
+              <a:srgbClr val="DAE0E9"/>
+            </a:solidFill>
+          </a:ln>
+        </p:spPr>
+        <p:style>
+          <a:lnRef idx="1">
+            <a:schemeClr val="accent1"/>
+          </a:lnRef>
+          <a:fillRef idx="3">
+            <a:schemeClr val="accent1"/>
+          </a:fillRef>
+          <a:effectRef idx="2">
+            <a:schemeClr val="accent1"/>
+          </a:effectRef>
+          <a:fontRef idx="minor">
+            <a:schemeClr val="lt1"/>
+          </a:fontRef>
+        </p:style>
+        <p:txBody>
+          <a:bodyPr rtlCol="0" anchor="ctr"/>
+          <a:lstStyle/>
+          <a:p>
+            <a:pPr algn="ctr"/>
+          </a:p>
+        </p:txBody>
+      </p:sp>
+      <p:sp>
+        <p:nvSpPr>
+          <p:cNvPr id="12" name="TextBox 11"/>
+          <p:cNvSpPr txBox="1"/>
+          <p:nvPr/>
+        </p:nvSpPr>
+        <p:spPr>
+          <a:xfrm>
+            <a:off x="868680" y="4069080"/>
+            <a:ext cx="914400" cy="457200"/>
+          </a:xfrm>
+          <a:prstGeom prst="rect">
+            <a:avLst/>
+          </a:prstGeom>
+          <a:noFill/>
+        </p:spPr>
+        <p:txBody>
+          <a:bodyPr wrap="none">
+            <a:spAutoFit/>
+          </a:bodyPr>
+          <a:lstStyle/>
+          <a:p>
+            <a:pPr>
+              <a:defRPr sz="2400" b="1">
+                <a:solidFill>
+                  <a:srgbClr val="B48C28"/>
+                </a:solidFill>
+                <a:latin typeface="Georgia"/>
+              </a:defRPr>
+            </a:pPr>
+            <a:r>
+              <a:t>03</a:t>
+            </a:r>
+          </a:p>
+        </p:txBody>
+      </p:sp>
+      <p:sp>
+        <p:nvSpPr>
+          <p:cNvPr id="13" name="TextBox 12"/>
+          <p:cNvSpPr txBox="1"/>
+          <p:nvPr/>
+        </p:nvSpPr>
+        <p:spPr>
+          <a:xfrm>
+            <a:off x="1600200" y="4069080"/>
+            <a:ext cx="4114800" cy="1828800"/>
+          </a:xfrm>
+          <a:prstGeom prst="rect">
+            <a:avLst/>
+          </a:prstGeom>
+          <a:noFill/>
+        </p:spPr>
+        <p:txBody>
+          <a:bodyPr wrap="square">
+            <a:spAutoFit/>
+          </a:bodyPr>
+          <a:lstStyle/>
           <a:p>
             <a:pPr>
               <a:spcAft>
-                <a:spcPts val="1000"/>
+                <a:spcPts val="600"/>
               </a:spcAft>
-              <a:defRPr sz="1500">
-                <a:solidFill>
-                  <a:srgbClr val="323232"/>
+              <a:defRPr sz="1800" b="1">
+                <a:solidFill>
+                  <a:srgbClr val="102C57"/>
                 </a:solidFill>
                 <a:latin typeface="Arial"/>
               </a:defRPr>
             </a:pPr>
             <a:r>
-              <a:t>    Lawyers waste valuable hours search-filtering thousands of historical judgments to identify matching case facts and sections.</a:t>
+              <a:t>Tedious Manual Retrieval</a:t>
             </a:r>
           </a:p>
           <a:p>
             <a:pPr>
-              <a:spcBef>
-                <a:spcPts val="800"/>
-              </a:spcBef>
-              <a:spcAft>
-                <a:spcPts val="200"/>
-              </a:spcAft>
-              <a:defRPr b="1" sz="1800">
-                <a:solidFill>
-                  <a:srgbClr val="102C57"/>
+              <a:defRPr sz="1400">
+                <a:solidFill>
+                  <a:srgbClr val="282828"/>
                 </a:solidFill>
                 <a:latin typeface="Arial"/>
               </a:defRPr>
             </a:pPr>
             <a:r>
-              <a:t>•  Absence of Explainable Predictive Tech: </a:t>
-            </a:r>
-          </a:p>
+              <a:t>Advocates waste critical hours cross-referencing vast judgment databases for matching facts.</a:t>
+            </a:r>
+          </a:p>
+        </p:txBody>
+      </p:sp>
+      <p:sp>
+        <p:nvSpPr>
+          <p:cNvPr id="14" name="Rounded Rectangle 13"/>
+          <p:cNvSpPr/>
+          <p:nvPr/>
+        </p:nvSpPr>
+        <p:spPr>
+          <a:xfrm>
+            <a:off x="6172200" y="3931920"/>
+            <a:ext cx="5303520" cy="2103120"/>
+          </a:xfrm>
+          <a:prstGeom prst="roundRect">
+            <a:avLst/>
+          </a:prstGeom>
+          <a:solidFill>
+            <a:srgbClr val="FFFFFF"/>
+          </a:solidFill>
+          <a:ln w="12700">
+            <a:solidFill>
+              <a:srgbClr val="DAE0E9"/>
+            </a:solidFill>
+          </a:ln>
+        </p:spPr>
+        <p:style>
+          <a:lnRef idx="1">
+            <a:schemeClr val="accent1"/>
+          </a:lnRef>
+          <a:fillRef idx="3">
+            <a:schemeClr val="accent1"/>
+          </a:fillRef>
+          <a:effectRef idx="2">
+            <a:schemeClr val="accent1"/>
+          </a:effectRef>
+          <a:fontRef idx="minor">
+            <a:schemeClr val="lt1"/>
+          </a:fontRef>
+        </p:style>
+        <p:txBody>
+          <a:bodyPr rtlCol="0" anchor="ctr"/>
+          <a:lstStyle/>
+          <a:p>
+            <a:pPr algn="ctr"/>
+          </a:p>
+        </p:txBody>
+      </p:sp>
+      <p:sp>
+        <p:nvSpPr>
+          <p:cNvPr id="15" name="TextBox 14"/>
+          <p:cNvSpPr txBox="1"/>
+          <p:nvPr/>
+        </p:nvSpPr>
+        <p:spPr>
+          <a:xfrm>
+            <a:off x="6355080" y="4069080"/>
+            <a:ext cx="914400" cy="457200"/>
+          </a:xfrm>
+          <a:prstGeom prst="rect">
+            <a:avLst/>
+          </a:prstGeom>
+          <a:noFill/>
+        </p:spPr>
+        <p:txBody>
+          <a:bodyPr wrap="none">
+            <a:spAutoFit/>
+          </a:bodyPr>
+          <a:lstStyle/>
+          <a:p>
+            <a:pPr>
+              <a:defRPr sz="2400" b="1">
+                <a:solidFill>
+                  <a:srgbClr val="B48C28"/>
+                </a:solidFill>
+                <a:latin typeface="Georgia"/>
+              </a:defRPr>
+            </a:pPr>
+            <a:r>
+              <a:t>04</a:t>
+            </a:r>
+          </a:p>
+        </p:txBody>
+      </p:sp>
+      <p:sp>
+        <p:nvSpPr>
+          <p:cNvPr id="16" name="TextBox 15"/>
+          <p:cNvSpPr txBox="1"/>
+          <p:nvPr/>
+        </p:nvSpPr>
+        <p:spPr>
+          <a:xfrm>
+            <a:off x="7086600" y="4069080"/>
+            <a:ext cx="4114800" cy="1828800"/>
+          </a:xfrm>
+          <a:prstGeom prst="rect">
+            <a:avLst/>
+          </a:prstGeom>
+          <a:noFill/>
+        </p:spPr>
+        <p:txBody>
+          <a:bodyPr wrap="square">
+            <a:spAutoFit/>
+          </a:bodyPr>
+          <a:lstStyle/>
           <a:p>
             <a:pPr>
               <a:spcAft>
-                <a:spcPts val="1000"/>
+                <a:spcPts val="600"/>
               </a:spcAft>
-              <a:defRPr sz="1500">
-                <a:solidFill>
-                  <a:srgbClr val="323232"/>
+              <a:defRPr sz="1800" b="1">
+                <a:solidFill>
+                  <a:srgbClr val="102C57"/>
                 </a:solidFill>
                 <a:latin typeface="Arial"/>
               </a:defRPr>
             </a:pPr>
             <a:r>
-              <a:t>    There is no open, evidence-based simulation framework to evaluate how evidence variations impact outcome probability.</a:t>
+              <a:t>Inflexible Case Planning</a:t>
+            </a:r>
+          </a:p>
+          <a:p>
+            <a:pPr>
+              <a:defRPr sz="1400">
+                <a:solidFill>
+                  <a:srgbClr val="282828"/>
+                </a:solidFill>
+                <a:latin typeface="Arial"/>
+              </a:defRPr>
+            </a:pPr>
+            <a:r>
+              <a:t>No quantitative tools to simulate 'what-if' scenarios based on different evidence/argument strengths.</a:t>
             </a:r>
           </a:p>
         </p:txBody>
@@ -3553,14 +4023,57 @@
       <p:grpSpPr/>
       <p:sp>
         <p:nvSpPr>
-          <p:cNvPr id="2" name="TextBox 1"/>
+          <p:cNvPr id="2" name="Rectangle 1"/>
+          <p:cNvSpPr/>
+          <p:nvPr/>
+        </p:nvSpPr>
+        <p:spPr>
+          <a:xfrm>
+            <a:off x="0" y="0"/>
+            <a:ext cx="12191695" cy="6858000"/>
+          </a:xfrm>
+          <a:prstGeom prst="rect">
+            <a:avLst/>
+          </a:prstGeom>
+          <a:solidFill>
+            <a:srgbClr val="F5F7FA"/>
+          </a:solidFill>
+          <a:ln>
+            <a:noFill/>
+          </a:ln>
+        </p:spPr>
+        <p:style>
+          <a:lnRef idx="1">
+            <a:schemeClr val="accent1"/>
+          </a:lnRef>
+          <a:fillRef idx="3">
+            <a:schemeClr val="accent1"/>
+          </a:fillRef>
+          <a:effectRef idx="2">
+            <a:schemeClr val="accent1"/>
+          </a:effectRef>
+          <a:fontRef idx="minor">
+            <a:schemeClr val="lt1"/>
+          </a:fontRef>
+        </p:style>
+        <p:txBody>
+          <a:bodyPr rtlCol="0" anchor="ctr"/>
+          <a:lstStyle/>
+          <a:p>
+            <a:pPr algn="ctr"/>
+          </a:p>
+        </p:txBody>
+      </p:sp>
+      <p:sp>
+        <p:nvSpPr>
+          <p:cNvPr id="3" name="TextBox 2"/>
           <p:cNvSpPr txBox="1"/>
           <p:nvPr/>
         </p:nvSpPr>
         <p:spPr>
           <a:xfrm>
             <a:off x="685800" y="365760"/>
-            <a:ext cx="10789920" cy="914400"/>
+            <a:ext cx="10817352" cy="731520"/>
           </a:xfrm>
           <a:prstGeom prst="rect">
             <a:avLst/>
@@ -3574,7 +4087,7 @@
           <a:lstStyle/>
           <a:p>
             <a:pPr>
-              <a:defRPr sz="3600" b="1">
+              <a:defRPr sz="3200" b="1">
                 <a:solidFill>
                   <a:srgbClr val="102C57"/>
                 </a:solidFill>
@@ -3582,21 +4095,21 @@
               </a:defRPr>
             </a:pPr>
             <a:r>
-              <a:t>2) Objectives &amp; Core Functionalities</a:t>
-            </a:r>
-          </a:p>
-        </p:txBody>
-      </p:sp>
-      <p:sp>
-        <p:nvSpPr>
-          <p:cNvPr id="3" name="Rectangle 2"/>
+              <a:t>2) Objectives (Core Functionalities)</a:t>
+            </a:r>
+          </a:p>
+        </p:txBody>
+      </p:sp>
+      <p:sp>
+        <p:nvSpPr>
+          <p:cNvPr id="4" name="Rectangle 3"/>
           <p:cNvSpPr/>
           <p:nvPr/>
         </p:nvSpPr>
         <p:spPr>
           <a:xfrm>
-            <a:off x="685800" y="1097280"/>
-            <a:ext cx="10817352" cy="36576"/>
+            <a:off x="685800" y="1051560"/>
+            <a:ext cx="1371600" cy="45720"/>
           </a:xfrm>
           <a:prstGeom prst="rect">
             <a:avLst/>
@@ -3632,14 +4145,59 @@
       </p:sp>
       <p:sp>
         <p:nvSpPr>
-          <p:cNvPr id="4" name="TextBox 3"/>
+          <p:cNvPr id="5" name="Rounded Rectangle 4"/>
+          <p:cNvSpPr/>
+          <p:nvPr/>
+        </p:nvSpPr>
+        <p:spPr>
+          <a:xfrm>
+            <a:off x="685800" y="1463040"/>
+            <a:ext cx="5212080" cy="4572000"/>
+          </a:xfrm>
+          <a:prstGeom prst="roundRect">
+            <a:avLst/>
+          </a:prstGeom>
+          <a:solidFill>
+            <a:srgbClr val="FFFFFF"/>
+          </a:solidFill>
+          <a:ln w="12700">
+            <a:solidFill>
+              <a:srgbClr val="DAE0E9"/>
+            </a:solidFill>
+          </a:ln>
+        </p:spPr>
+        <p:style>
+          <a:lnRef idx="1">
+            <a:schemeClr val="accent1"/>
+          </a:lnRef>
+          <a:fillRef idx="3">
+            <a:schemeClr val="accent1"/>
+          </a:fillRef>
+          <a:effectRef idx="2">
+            <a:schemeClr val="accent1"/>
+          </a:effectRef>
+          <a:fontRef idx="minor">
+            <a:schemeClr val="lt1"/>
+          </a:fontRef>
+        </p:style>
+        <p:txBody>
+          <a:bodyPr rtlCol="0" anchor="ctr"/>
+          <a:lstStyle/>
+          <a:p>
+            <a:pPr algn="ctr"/>
+          </a:p>
+        </p:txBody>
+      </p:sp>
+      <p:sp>
+        <p:nvSpPr>
+          <p:cNvPr id="6" name="TextBox 5"/>
           <p:cNvSpPr txBox="1"/>
           <p:nvPr/>
         </p:nvSpPr>
         <p:spPr>
           <a:xfrm>
-            <a:off x="685800" y="1463040"/>
-            <a:ext cx="5120640" cy="4572000"/>
+            <a:off x="868680" y="1645920"/>
+            <a:ext cx="4846320" cy="457200"/>
           </a:xfrm>
           <a:prstGeom prst="rect">
             <a:avLst/>
@@ -3647,113 +4205,35 @@
           <a:noFill/>
         </p:spPr>
         <p:txBody>
-          <a:bodyPr wrap="square">
+          <a:bodyPr wrap="none">
             <a:spAutoFit/>
           </a:bodyPr>
           <a:lstStyle/>
-          <a:p/>
           <a:p>
             <a:pPr>
-              <a:spcBef>
-                <a:spcPts val="1000"/>
-              </a:spcBef>
-              <a:defRPr b="1" sz="1800">
-                <a:solidFill>
-                  <a:srgbClr val="102C57"/>
-                </a:solidFill>
+              <a:defRPr sz="2000" b="1">
+                <a:solidFill>
+                  <a:srgbClr val="B48C28"/>
+                </a:solidFill>
+                <a:latin typeface="Georgia"/>
               </a:defRPr>
             </a:pPr>
             <a:r>
-              <a:t>✓  Natural Language Analysis</a:t>
-            </a:r>
-          </a:p>
-          <a:p>
-            <a:pPr>
-              <a:spcAft>
-                <a:spcPts val="1000"/>
-              </a:spcAft>
-              <a:defRPr sz="1400">
-                <a:solidFill>
-                  <a:srgbClr val="323232"/>
-                </a:solidFill>
-              </a:defRPr>
-            </a:pPr>
-            <a:r>
-              <a:t>    Allows users to write problems in plain text; automatically parses timelines, key entities, and disputes.</a:t>
-            </a:r>
-          </a:p>
-          <a:p>
-            <a:pPr>
-              <a:spcBef>
-                <a:spcPts val="1000"/>
-              </a:spcBef>
-              <a:defRPr b="1" sz="1800">
-                <a:solidFill>
-                  <a:srgbClr val="102C57"/>
-                </a:solidFill>
-              </a:defRPr>
-            </a:pPr>
-            <a:r>
-              <a:t>✓  Statutory Provisions Matcher</a:t>
-            </a:r>
-          </a:p>
-          <a:p>
-            <a:pPr>
-              <a:spcAft>
-                <a:spcPts val="1000"/>
-              </a:spcAft>
-              <a:defRPr sz="1400">
-                <a:solidFill>
-                  <a:srgbClr val="323232"/>
-                </a:solidFill>
-              </a:defRPr>
-            </a:pPr>
-            <a:r>
-              <a:t>    Leverages NLP to extract legal topics and map matches to IPC/BNS sections dynamically.</a:t>
-            </a:r>
-          </a:p>
-          <a:p>
-            <a:pPr>
-              <a:spcBef>
-                <a:spcPts val="1000"/>
-              </a:spcBef>
-              <a:defRPr b="1" sz="1800">
-                <a:solidFill>
-                  <a:srgbClr val="102C57"/>
-                </a:solidFill>
-              </a:defRPr>
-            </a:pPr>
-            <a:r>
-              <a:t>✓  Precedent Retrieval Engine</a:t>
-            </a:r>
-          </a:p>
-          <a:p>
-            <a:pPr>
-              <a:spcAft>
-                <a:spcPts val="1000"/>
-              </a:spcAft>
-              <a:defRPr sz="1400">
-                <a:solidFill>
-                  <a:srgbClr val="323232"/>
-                </a:solidFill>
-              </a:defRPr>
-            </a:pPr>
-            <a:r>
-              <a:t>    Queries historical records using cosine similarity to isolate top similar judgments.</a:t>
-            </a:r>
-          </a:p>
-        </p:txBody>
-      </p:sp>
-      <p:sp>
-        <p:nvSpPr>
-          <p:cNvPr id="5" name="TextBox 4"/>
+              <a:t>User Input &amp; Similarity Engine</a:t>
+            </a:r>
+          </a:p>
+        </p:txBody>
+      </p:sp>
+      <p:sp>
+        <p:nvSpPr>
+          <p:cNvPr id="7" name="TextBox 6"/>
           <p:cNvSpPr txBox="1"/>
           <p:nvPr/>
         </p:nvSpPr>
         <p:spPr>
           <a:xfrm>
-            <a:off x="6309360" y="1463040"/>
-            <a:ext cx="5120640" cy="4572000"/>
+            <a:off x="868680" y="2194560"/>
+            <a:ext cx="4846320" cy="3657600"/>
           </a:xfrm>
           <a:prstGeom prst="rect">
             <a:avLst/>
@@ -3768,92 +4248,215 @@
           <a:p/>
           <a:p>
             <a:pPr>
-              <a:spcBef>
-                <a:spcPts val="1000"/>
-              </a:spcBef>
-              <a:defRPr b="1" sz="1800">
-                <a:solidFill>
-                  <a:srgbClr val="102C57"/>
+              <a:spcAft>
+                <a:spcPts val="1200"/>
+              </a:spcAft>
+              <a:defRPr b="1" sz="1400">
+                <a:solidFill>
+                  <a:srgbClr val="282828"/>
                 </a:solidFill>
               </a:defRPr>
             </a:pPr>
             <a:r>
-              <a:t>✓  Outcome Prediction Model</a:t>
+              <a:t>✓  Natural Language Parse: </a:t>
+            </a:r>
+            <a:r>
+              <a:t>Extracts legal timelines and entities from raw text.</a:t>
             </a:r>
           </a:p>
           <a:p>
             <a:pPr>
               <a:spcAft>
-                <a:spcPts val="1000"/>
+                <a:spcPts val="1200"/>
               </a:spcAft>
-              <a:defRPr sz="1400">
-                <a:solidFill>
-                  <a:srgbClr val="323232"/>
+              <a:defRPr b="1" sz="1400">
+                <a:solidFill>
+                  <a:srgbClr val="282828"/>
                 </a:solidFill>
               </a:defRPr>
             </a:pPr>
             <a:r>
-              <a:t>    Provides evidence-based assessments showing reasoning, citations, and confidence metrics.</a:t>
-            </a:r>
-          </a:p>
-          <a:p>
-            <a:pPr>
-              <a:spcBef>
-                <a:spcPts val="1000"/>
-              </a:spcBef>
-              <a:defRPr b="1" sz="1800">
-                <a:solidFill>
-                  <a:srgbClr val="102C57"/>
-                </a:solidFill>
-              </a:defRPr>
-            </a:pPr>
-            <a:r>
-              <a:t>✓  Factual 'What-If' Simulator</a:t>
+              <a:t>✓  Statute Mapping: </a:t>
+            </a:r>
+            <a:r>
+              <a:t>Automatically matches parsed queries to active legal provisions (IPC/BNS).</a:t>
             </a:r>
           </a:p>
           <a:p>
             <a:pPr>
               <a:spcAft>
-                <a:spcPts val="1000"/>
+                <a:spcPts val="1200"/>
               </a:spcAft>
-              <a:defRPr sz="1400">
-                <a:solidFill>
-                  <a:srgbClr val="323232"/>
+              <a:defRPr b="1" sz="1400">
+                <a:solidFill>
+                  <a:srgbClr val="282828"/>
                 </a:solidFill>
               </a:defRPr>
             </a:pPr>
             <a:r>
-              <a:t>    Enables lawyers to toggle evidence strength to evaluate outcome probability variations.</a:t>
-            </a:r>
-          </a:p>
+              <a:t>✓  Semantic retrieval: </a:t>
+            </a:r>
+            <a:r>
+              <a:t>Employs Cosine Similarity vector matching to fetch closest historical precedents.</a:t>
+            </a:r>
+          </a:p>
+        </p:txBody>
+      </p:sp>
+      <p:sp>
+        <p:nvSpPr>
+          <p:cNvPr id="8" name="Rounded Rectangle 7"/>
+          <p:cNvSpPr/>
+          <p:nvPr/>
+        </p:nvSpPr>
+        <p:spPr>
+          <a:xfrm>
+            <a:off x="6291072" y="1463040"/>
+            <a:ext cx="5212080" cy="4572000"/>
+          </a:xfrm>
+          <a:prstGeom prst="roundRect">
+            <a:avLst/>
+          </a:prstGeom>
+          <a:solidFill>
+            <a:srgbClr val="FFFFFF"/>
+          </a:solidFill>
+          <a:ln w="12700">
+            <a:solidFill>
+              <a:srgbClr val="DAE0E9"/>
+            </a:solidFill>
+          </a:ln>
+        </p:spPr>
+        <p:style>
+          <a:lnRef idx="1">
+            <a:schemeClr val="accent1"/>
+          </a:lnRef>
+          <a:fillRef idx="3">
+            <a:schemeClr val="accent1"/>
+          </a:fillRef>
+          <a:effectRef idx="2">
+            <a:schemeClr val="accent1"/>
+          </a:effectRef>
+          <a:fontRef idx="minor">
+            <a:schemeClr val="lt1"/>
+          </a:fontRef>
+        </p:style>
+        <p:txBody>
+          <a:bodyPr rtlCol="0" anchor="ctr"/>
+          <a:lstStyle/>
+          <a:p>
+            <a:pPr algn="ctr"/>
+          </a:p>
+        </p:txBody>
+      </p:sp>
+      <p:sp>
+        <p:nvSpPr>
+          <p:cNvPr id="9" name="TextBox 8"/>
+          <p:cNvSpPr txBox="1"/>
+          <p:nvPr/>
+        </p:nvSpPr>
+        <p:spPr>
+          <a:xfrm>
+            <a:off x="6473952" y="1645920"/>
+            <a:ext cx="4846320" cy="457200"/>
+          </a:xfrm>
+          <a:prstGeom prst="rect">
+            <a:avLst/>
+          </a:prstGeom>
+          <a:noFill/>
+        </p:spPr>
+        <p:txBody>
+          <a:bodyPr wrap="none">
+            <a:spAutoFit/>
+          </a:bodyPr>
+          <a:lstStyle/>
           <a:p>
             <a:pPr>
-              <a:spcBef>
-                <a:spcPts val="1000"/>
-              </a:spcBef>
-              <a:defRPr b="1" sz="1800">
-                <a:solidFill>
-                  <a:srgbClr val="102C57"/>
-                </a:solidFill>
+              <a:defRPr sz="2000" b="1">
+                <a:solidFill>
+                  <a:srgbClr val="B48C28"/>
+                </a:solidFill>
+                <a:latin typeface="Georgia"/>
               </a:defRPr>
             </a:pPr>
             <a:r>
-              <a:t>✓  Automated Report Generator</a:t>
-            </a:r>
-          </a:p>
+              <a:t>Analytics &amp; Report Engine</a:t>
+            </a:r>
+          </a:p>
+        </p:txBody>
+      </p:sp>
+      <p:sp>
+        <p:nvSpPr>
+          <p:cNvPr id="10" name="TextBox 9"/>
+          <p:cNvSpPr txBox="1"/>
+          <p:nvPr/>
+        </p:nvSpPr>
+        <p:spPr>
+          <a:xfrm>
+            <a:off x="6473952" y="2194560"/>
+            <a:ext cx="4846320" cy="3657600"/>
+          </a:xfrm>
+          <a:prstGeom prst="rect">
+            <a:avLst/>
+          </a:prstGeom>
+          <a:noFill/>
+        </p:spPr>
+        <p:txBody>
+          <a:bodyPr wrap="square">
+            <a:spAutoFit/>
+          </a:bodyPr>
+          <a:lstStyle/>
+          <a:p/>
           <a:p>
             <a:pPr>
               <a:spcAft>
-                <a:spcPts val="1000"/>
+                <a:spcPts val="1200"/>
               </a:spcAft>
-              <a:defRPr sz="1400">
-                <a:solidFill>
-                  <a:srgbClr val="323232"/>
+              <a:defRPr b="1" sz="1400">
+                <a:solidFill>
+                  <a:srgbClr val="282828"/>
                 </a:solidFill>
               </a:defRPr>
             </a:pPr>
             <a:r>
-              <a:t>    Synthesizes analyses, laws, and outcomes into downloadable PDF case dockets.</a:t>
+              <a:t>✓  Evidence Predictor: </a:t>
+            </a:r>
+            <a:r>
+              <a:t>Forecasts outcome probabilities based on historical weights &amp; classification.</a:t>
+            </a:r>
+          </a:p>
+          <a:p>
+            <a:pPr>
+              <a:spcAft>
+                <a:spcPts val="1200"/>
+              </a:spcAft>
+              <a:defRPr b="1" sz="1400">
+                <a:solidFill>
+                  <a:srgbClr val="282828"/>
+                </a:solidFill>
+              </a:defRPr>
+            </a:pPr>
+            <a:r>
+              <a:t>✓  What-If Simulator: </a:t>
+            </a:r>
+            <a:r>
+              <a:t>Enables advocates to test argument variables and see changes dynamically.</a:t>
+            </a:r>
+          </a:p>
+          <a:p>
+            <a:pPr>
+              <a:spcAft>
+                <a:spcPts val="1200"/>
+              </a:spcAft>
+              <a:defRPr b="1" sz="1400">
+                <a:solidFill>
+                  <a:srgbClr val="282828"/>
+                </a:solidFill>
+              </a:defRPr>
+            </a:pPr>
+            <a:r>
+              <a:t>✓  Executive PDF Export: </a:t>
+            </a:r>
+            <a:r>
+              <a:t>Builds downloadable PDF dockets with summaries, citations, and metrics.</a:t>
             </a:r>
           </a:p>
         </p:txBody>
@@ -3878,14 +4481,57 @@
       <p:grpSpPr/>
       <p:sp>
         <p:nvSpPr>
-          <p:cNvPr id="2" name="TextBox 1"/>
+          <p:cNvPr id="2" name="Rectangle 1"/>
+          <p:cNvSpPr/>
+          <p:nvPr/>
+        </p:nvSpPr>
+        <p:spPr>
+          <a:xfrm>
+            <a:off x="0" y="0"/>
+            <a:ext cx="12191695" cy="6858000"/>
+          </a:xfrm>
+          <a:prstGeom prst="rect">
+            <a:avLst/>
+          </a:prstGeom>
+          <a:solidFill>
+            <a:srgbClr val="F5F7FA"/>
+          </a:solidFill>
+          <a:ln>
+            <a:noFill/>
+          </a:ln>
+        </p:spPr>
+        <p:style>
+          <a:lnRef idx="1">
+            <a:schemeClr val="accent1"/>
+          </a:lnRef>
+          <a:fillRef idx="3">
+            <a:schemeClr val="accent1"/>
+          </a:fillRef>
+          <a:effectRef idx="2">
+            <a:schemeClr val="accent1"/>
+          </a:effectRef>
+          <a:fontRef idx="minor">
+            <a:schemeClr val="lt1"/>
+          </a:fontRef>
+        </p:style>
+        <p:txBody>
+          <a:bodyPr rtlCol="0" anchor="ctr"/>
+          <a:lstStyle/>
+          <a:p>
+            <a:pPr algn="ctr"/>
+          </a:p>
+        </p:txBody>
+      </p:sp>
+      <p:sp>
+        <p:nvSpPr>
+          <p:cNvPr id="3" name="TextBox 2"/>
           <p:cNvSpPr txBox="1"/>
           <p:nvPr/>
         </p:nvSpPr>
         <p:spPr>
           <a:xfrm>
             <a:off x="685800" y="365760"/>
-            <a:ext cx="10789920" cy="914400"/>
+            <a:ext cx="10817352" cy="731520"/>
           </a:xfrm>
           <a:prstGeom prst="rect">
             <a:avLst/>
@@ -3899,7 +4545,7 @@
           <a:lstStyle/>
           <a:p>
             <a:pPr>
-              <a:defRPr sz="3600" b="1">
+              <a:defRPr sz="3200" b="1">
                 <a:solidFill>
                   <a:srgbClr val="102C57"/>
                 </a:solidFill>
@@ -3914,14 +4560,14 @@
       </p:sp>
       <p:sp>
         <p:nvSpPr>
-          <p:cNvPr id="3" name="Rectangle 2"/>
+          <p:cNvPr id="4" name="Rectangle 3"/>
           <p:cNvSpPr/>
           <p:nvPr/>
         </p:nvSpPr>
         <p:spPr>
           <a:xfrm>
-            <a:off x="685800" y="1097280"/>
-            <a:ext cx="10817352" cy="36576"/>
+            <a:off x="685800" y="1051560"/>
+            <a:ext cx="1371600" cy="45720"/>
           </a:xfrm>
           <a:prstGeom prst="rect">
             <a:avLst/>
@@ -3957,14 +4603,59 @@
       </p:sp>
       <p:sp>
         <p:nvSpPr>
-          <p:cNvPr id="4" name="TextBox 3"/>
+          <p:cNvPr id="5" name="Rounded Rectangle 4"/>
+          <p:cNvSpPr/>
+          <p:nvPr/>
+        </p:nvSpPr>
+        <p:spPr>
+          <a:xfrm>
+            <a:off x="685800" y="1463040"/>
+            <a:ext cx="5212080" cy="4572000"/>
+          </a:xfrm>
+          <a:prstGeom prst="roundRect">
+            <a:avLst/>
+          </a:prstGeom>
+          <a:solidFill>
+            <a:srgbClr val="FFFFFF"/>
+          </a:solidFill>
+          <a:ln w="12700">
+            <a:solidFill>
+              <a:srgbClr val="DAE0E9"/>
+            </a:solidFill>
+          </a:ln>
+        </p:spPr>
+        <p:style>
+          <a:lnRef idx="1">
+            <a:schemeClr val="accent1"/>
+          </a:lnRef>
+          <a:fillRef idx="3">
+            <a:schemeClr val="accent1"/>
+          </a:fillRef>
+          <a:effectRef idx="2">
+            <a:schemeClr val="accent1"/>
+          </a:effectRef>
+          <a:fontRef idx="minor">
+            <a:schemeClr val="lt1"/>
+          </a:fontRef>
+        </p:style>
+        <p:txBody>
+          <a:bodyPr rtlCol="0" anchor="ctr"/>
+          <a:lstStyle/>
+          <a:p>
+            <a:pPr algn="ctr"/>
+          </a:p>
+        </p:txBody>
+      </p:sp>
+      <p:sp>
+        <p:nvSpPr>
+          <p:cNvPr id="6" name="TextBox 5"/>
           <p:cNvSpPr txBox="1"/>
           <p:nvPr/>
         </p:nvSpPr>
         <p:spPr>
           <a:xfrm>
-            <a:off x="685800" y="1463040"/>
-            <a:ext cx="5120640" cy="4572000"/>
+            <a:off x="868680" y="1645920"/>
+            <a:ext cx="4846320" cy="457200"/>
           </a:xfrm>
           <a:prstGeom prst="rect">
             <a:avLst/>
@@ -3972,6 +4663,42 @@
           <a:noFill/>
         </p:spPr>
         <p:txBody>
+          <a:bodyPr wrap="none">
+            <a:spAutoFit/>
+          </a:bodyPr>
+          <a:lstStyle/>
+          <a:p>
+            <a:pPr>
+              <a:defRPr sz="2000" b="1">
+                <a:solidFill>
+                  <a:srgbClr val="102C57"/>
+                </a:solidFill>
+                <a:latin typeface="Georgia"/>
+              </a:defRPr>
+            </a:pPr>
+            <a:r>
+              <a:t>Software Specifications</a:t>
+            </a:r>
+          </a:p>
+        </p:txBody>
+      </p:sp>
+      <p:sp>
+        <p:nvSpPr>
+          <p:cNvPr id="7" name="TextBox 6"/>
+          <p:cNvSpPr txBox="1"/>
+          <p:nvPr/>
+        </p:nvSpPr>
+        <p:spPr>
+          <a:xfrm>
+            <a:off x="868680" y="2194560"/>
+            <a:ext cx="4846320" cy="3657600"/>
+          </a:xfrm>
+          <a:prstGeom prst="rect">
+            <a:avLst/>
+          </a:prstGeom>
+          <a:noFill/>
+        </p:spPr>
+        <p:txBody>
           <a:bodyPr wrap="square">
             <a:spAutoFit/>
           </a:bodyPr>
@@ -3982,136 +4709,148 @@
               <a:spcAft>
                 <a:spcPts val="1200"/>
               </a:spcAft>
-              <a:defRPr b="1" sz="2200">
-                <a:solidFill>
-                  <a:srgbClr val="B48C28"/>
+              <a:defRPr b="1" sz="1400">
+                <a:solidFill>
+                  <a:srgbClr val="282828"/>
                 </a:solidFill>
               </a:defRPr>
             </a:pPr>
             <a:r>
-              <a:t>Software Specifications</a:t>
+              <a:t>•  UI &amp; Styling: </a:t>
+            </a:r>
+            <a:r>
+              <a:t>React (TypeScript), Tailwind CSS v4, Recharts</a:t>
             </a:r>
           </a:p>
           <a:p>
             <a:pPr>
               <a:spcAft>
-                <a:spcPts val="600"/>
+                <a:spcPts val="1200"/>
               </a:spcAft>
-              <a:defRPr b="1" sz="1500">
-                <a:solidFill>
-                  <a:srgbClr val="102C57"/>
+              <a:defRPr b="1" sz="1400">
+                <a:solidFill>
+                  <a:srgbClr val="282828"/>
                 </a:solidFill>
               </a:defRPr>
             </a:pPr>
             <a:r>
-              <a:t>•  Frontend: </a:t>
-            </a:r>
-            <a:r>
-              <a:t>React (TypeScript), Tailwind CSS v4, Recharts</a:t>
+              <a:t>•  API &amp; Server: </a:t>
+            </a:r>
+            <a:r>
+              <a:t>FastAPI (Python 3.12), SQLAlchemy ORM</a:t>
             </a:r>
           </a:p>
           <a:p>
             <a:pPr>
               <a:spcAft>
-                <a:spcPts val="600"/>
+                <a:spcPts val="1200"/>
               </a:spcAft>
-              <a:defRPr b="1" sz="1500">
-                <a:solidFill>
-                  <a:srgbClr val="102C57"/>
+              <a:defRPr b="1" sz="1400">
+                <a:solidFill>
+                  <a:srgbClr val="282828"/>
                 </a:solidFill>
               </a:defRPr>
             </a:pPr>
             <a:r>
-              <a:t>•  Backend Framework: </a:t>
-            </a:r>
-            <a:r>
-              <a:t>FastAPI (Python 3.12), SQLAlchemy ORM</a:t>
+              <a:t>•  Database: </a:t>
+            </a:r>
+            <a:r>
+              <a:t>Supabase (Cloud PostgreSQL)</a:t>
             </a:r>
           </a:p>
           <a:p>
             <a:pPr>
               <a:spcAft>
-                <a:spcPts val="600"/>
+                <a:spcPts val="1200"/>
               </a:spcAft>
-              <a:defRPr b="1" sz="1500">
-                <a:solidFill>
-                  <a:srgbClr val="102C57"/>
+              <a:defRPr b="1" sz="1400">
+                <a:solidFill>
+                  <a:srgbClr val="282828"/>
                 </a:solidFill>
               </a:defRPr>
             </a:pPr>
             <a:r>
-              <a:t>•  Database: </a:t>
-            </a:r>
-            <a:r>
-              <a:t>Supabase (Cloud PostgreSQL)</a:t>
+              <a:t>•  ML &amp; NLP Core: </a:t>
+            </a:r>
+            <a:r>
+              <a:t>Scikit-learn, NLTK, TF-IDF Vecs</a:t>
             </a:r>
           </a:p>
           <a:p>
             <a:pPr>
               <a:spcAft>
-                <a:spcPts val="600"/>
+                <a:spcPts val="1200"/>
               </a:spcAft>
-              <a:defRPr b="1" sz="1500">
-                <a:solidFill>
-                  <a:srgbClr val="102C57"/>
+              <a:defRPr b="1" sz="1400">
+                <a:solidFill>
+                  <a:srgbClr val="282828"/>
                 </a:solidFill>
               </a:defRPr>
             </a:pPr>
             <a:r>
-              <a:t>•  Text Processing: </a:t>
-            </a:r>
-            <a:r>
-              <a:t>NLTK, Scikit-learn (TF-IDF, Cosine Similarity)</a:t>
-            </a:r>
-          </a:p>
-          <a:p>
-            <a:pPr>
-              <a:spcAft>
-                <a:spcPts val="600"/>
-              </a:spcAft>
-              <a:defRPr b="1" sz="1500">
-                <a:solidFill>
-                  <a:srgbClr val="102C57"/>
-                </a:solidFill>
-              </a:defRPr>
-            </a:pPr>
-            <a:r>
-              <a:t>•  Production Server: </a:t>
-            </a:r>
-            <a:r>
-              <a:t>Uvicorn, Gunicorn, Nginx</a:t>
-            </a:r>
-          </a:p>
-          <a:p>
-            <a:pPr>
-              <a:spcAft>
-                <a:spcPts val="600"/>
-              </a:spcAft>
-              <a:defRPr b="1" sz="1500">
-                <a:solidFill>
-                  <a:srgbClr val="102C57"/>
-                </a:solidFill>
-              </a:defRPr>
-            </a:pPr>
-            <a:r>
-              <a:t>•  Deployment platforms: </a:t>
-            </a:r>
-            <a:r>
-              <a:t>Vercel (Frontend), Docker Containers</a:t>
-            </a:r>
-          </a:p>
-        </p:txBody>
-      </p:sp>
-      <p:sp>
-        <p:nvSpPr>
-          <p:cNvPr id="5" name="TextBox 4"/>
+              <a:t>•  Deployment: </a:t>
+            </a:r>
+            <a:r>
+              <a:t>Vercel Web Portal, Docker Containers</a:t>
+            </a:r>
+          </a:p>
+        </p:txBody>
+      </p:sp>
+      <p:sp>
+        <p:nvSpPr>
+          <p:cNvPr id="8" name="Rounded Rectangle 7"/>
+          <p:cNvSpPr/>
+          <p:nvPr/>
+        </p:nvSpPr>
+        <p:spPr>
+          <a:xfrm>
+            <a:off x="6291072" y="1463040"/>
+            <a:ext cx="5212080" cy="4572000"/>
+          </a:xfrm>
+          <a:prstGeom prst="roundRect">
+            <a:avLst/>
+          </a:prstGeom>
+          <a:solidFill>
+            <a:srgbClr val="FFFFFF"/>
+          </a:solidFill>
+          <a:ln w="12700">
+            <a:solidFill>
+              <a:srgbClr val="DAE0E9"/>
+            </a:solidFill>
+          </a:ln>
+        </p:spPr>
+        <p:style>
+          <a:lnRef idx="1">
+            <a:schemeClr val="accent1"/>
+          </a:lnRef>
+          <a:fillRef idx="3">
+            <a:schemeClr val="accent1"/>
+          </a:fillRef>
+          <a:effectRef idx="2">
+            <a:schemeClr val="accent1"/>
+          </a:effectRef>
+          <a:fontRef idx="minor">
+            <a:schemeClr val="lt1"/>
+          </a:fontRef>
+        </p:style>
+        <p:txBody>
+          <a:bodyPr rtlCol="0" anchor="ctr"/>
+          <a:lstStyle/>
+          <a:p>
+            <a:pPr algn="ctr"/>
+          </a:p>
+        </p:txBody>
+      </p:sp>
+      <p:sp>
+        <p:nvSpPr>
+          <p:cNvPr id="9" name="TextBox 8"/>
           <p:cNvSpPr txBox="1"/>
           <p:nvPr/>
         </p:nvSpPr>
         <p:spPr>
           <a:xfrm>
-            <a:off x="6309360" y="1463040"/>
-            <a:ext cx="5120640" cy="4572000"/>
+            <a:off x="6473952" y="1645920"/>
+            <a:ext cx="4846320" cy="457200"/>
           </a:xfrm>
           <a:prstGeom prst="rect">
             <a:avLst/>
@@ -4119,6 +4858,42 @@
           <a:noFill/>
         </p:spPr>
         <p:txBody>
+          <a:bodyPr wrap="none">
+            <a:spAutoFit/>
+          </a:bodyPr>
+          <a:lstStyle/>
+          <a:p>
+            <a:pPr>
+              <a:defRPr sz="2000" b="1">
+                <a:solidFill>
+                  <a:srgbClr val="102C57"/>
+                </a:solidFill>
+                <a:latin typeface="Georgia"/>
+              </a:defRPr>
+            </a:pPr>
+            <a:r>
+              <a:t>Hardware Specifications</a:t>
+            </a:r>
+          </a:p>
+        </p:txBody>
+      </p:sp>
+      <p:sp>
+        <p:nvSpPr>
+          <p:cNvPr id="10" name="TextBox 9"/>
+          <p:cNvSpPr txBox="1"/>
+          <p:nvPr/>
+        </p:nvSpPr>
+        <p:spPr>
+          <a:xfrm>
+            <a:off x="6473952" y="2194560"/>
+            <a:ext cx="4846320" cy="3657600"/>
+          </a:xfrm>
+          <a:prstGeom prst="rect">
+            <a:avLst/>
+          </a:prstGeom>
+          <a:noFill/>
+        </p:spPr>
+        <p:txBody>
           <a:bodyPr wrap="square">
             <a:spAutoFit/>
           </a:bodyPr>
@@ -4129,122 +4904,89 @@
               <a:spcAft>
                 <a:spcPts val="1200"/>
               </a:spcAft>
-              <a:defRPr b="1" sz="2200">
-                <a:solidFill>
-                  <a:srgbClr val="B48C28"/>
+              <a:defRPr b="1" sz="1400">
+                <a:solidFill>
+                  <a:srgbClr val="282828"/>
                 </a:solidFill>
               </a:defRPr>
             </a:pPr>
             <a:r>
-              <a:t>Hardware Specifications</a:t>
+              <a:t>•  Processor: </a:t>
+            </a:r>
+            <a:r>
+              <a:t>Intel Core i5 / AMD Ryzen 5 or higher</a:t>
             </a:r>
           </a:p>
           <a:p>
             <a:pPr>
               <a:spcAft>
-                <a:spcPts val="600"/>
+                <a:spcPts val="1200"/>
               </a:spcAft>
-              <a:defRPr b="1" sz="1500">
-                <a:solidFill>
-                  <a:srgbClr val="102C57"/>
+              <a:defRPr b="1" sz="1400">
+                <a:solidFill>
+                  <a:srgbClr val="282828"/>
                 </a:solidFill>
               </a:defRPr>
             </a:pPr>
             <a:r>
-              <a:t>•  Processor: </a:t>
-            </a:r>
-            <a:r>
-              <a:t>Intel Core i5 / AMD Ryzen 5 or higher</a:t>
+              <a:t>•  System RAM: </a:t>
+            </a:r>
+            <a:r>
+              <a:t>8 GB DDR4 minimum (16 GB recommended)</a:t>
             </a:r>
           </a:p>
           <a:p>
             <a:pPr>
               <a:spcAft>
-                <a:spcPts val="600"/>
+                <a:spcPts val="1200"/>
               </a:spcAft>
-              <a:defRPr b="1" sz="1500">
-                <a:solidFill>
-                  <a:srgbClr val="102C57"/>
+              <a:defRPr b="1" sz="1400">
+                <a:solidFill>
+                  <a:srgbClr val="282828"/>
                 </a:solidFill>
               </a:defRPr>
             </a:pPr>
             <a:r>
-              <a:t>•  System Memory (RAM): </a:t>
-            </a:r>
-            <a:r>
-              <a:t>8 GB minimum (16 GB recommended)</a:t>
+              <a:t>•  Hard Drive: </a:t>
+            </a:r>
+            <a:r>
+              <a:t>256 GB NVMe SSD drive minimum</a:t>
             </a:r>
           </a:p>
           <a:p>
             <a:pPr>
               <a:spcAft>
-                <a:spcPts val="600"/>
+                <a:spcPts val="1200"/>
               </a:spcAft>
-              <a:defRPr b="1" sz="1500">
-                <a:solidFill>
-                  <a:srgbClr val="102C57"/>
+              <a:defRPr b="1" sz="1400">
+                <a:solidFill>
+                  <a:srgbClr val="282828"/>
                 </a:solidFill>
               </a:defRPr>
             </a:pPr>
             <a:r>
-              <a:t>•  Storage Drive: </a:t>
-            </a:r>
-            <a:r>
-              <a:t>256 GB SSD (Solid State Drive) minimum</a:t>
+              <a:t>•  Server Cluster: </a:t>
+            </a:r>
+            <a:r>
+              <a:t>Supabase Shared Cloud Core (AWS Hosting)</a:t>
             </a:r>
           </a:p>
           <a:p>
             <a:pPr>
               <a:spcAft>
-                <a:spcPts val="600"/>
+                <a:spcPts val="1200"/>
               </a:spcAft>
-              <a:defRPr b="1" sz="1500">
-                <a:solidFill>
-                  <a:srgbClr val="102C57"/>
+              <a:defRPr b="1" sz="1400">
+                <a:solidFill>
+                  <a:srgbClr val="282828"/>
                 </a:solidFill>
               </a:defRPr>
             </a:pPr>
             <a:r>
-              <a:t>•  Local Dev Host: </a:t>
-            </a:r>
-            <a:r>
-              <a:t>Localhost (Windows/Linux/macOS)</a:t>
-            </a:r>
-          </a:p>
-          <a:p>
-            <a:pPr>
-              <a:spcAft>
-                <a:spcPts val="600"/>
-              </a:spcAft>
-              <a:defRPr b="1" sz="1500">
-                <a:solidFill>
-                  <a:srgbClr val="102C57"/>
-                </a:solidFill>
-              </a:defRPr>
-            </a:pPr>
-            <a:r>
-              <a:t>•  Cloud Database Host: </a:t>
-            </a:r>
-            <a:r>
-              <a:t>Supabase Cloud Database Cluster</a:t>
-            </a:r>
-          </a:p>
-          <a:p>
-            <a:pPr>
-              <a:spcAft>
-                <a:spcPts val="600"/>
-              </a:spcAft>
-              <a:defRPr b="1" sz="1500">
-                <a:solidFill>
-                  <a:srgbClr val="102C57"/>
-                </a:solidFill>
-              </a:defRPr>
-            </a:pPr>
-            <a:r>
-              <a:t>•  Cloud Host Hosting: </a:t>
-            </a:r>
-            <a:r>
-              <a:t>Vercel Web Servers</a:t>
+              <a:t>•  Client Engine: </a:t>
+            </a:r>
+            <a:r>
+              <a:t>Web browser interface (Chrome / Edge / Firefox)</a:t>
             </a:r>
           </a:p>
         </p:txBody>
@@ -4269,14 +5011,57 @@
       <p:grpSpPr/>
       <p:sp>
         <p:nvSpPr>
-          <p:cNvPr id="2" name="TextBox 1"/>
+          <p:cNvPr id="2" name="Rectangle 1"/>
+          <p:cNvSpPr/>
+          <p:nvPr/>
+        </p:nvSpPr>
+        <p:spPr>
+          <a:xfrm>
+            <a:off x="0" y="0"/>
+            <a:ext cx="12191695" cy="6858000"/>
+          </a:xfrm>
+          <a:prstGeom prst="rect">
+            <a:avLst/>
+          </a:prstGeom>
+          <a:solidFill>
+            <a:srgbClr val="F5F7FA"/>
+          </a:solidFill>
+          <a:ln>
+            <a:noFill/>
+          </a:ln>
+        </p:spPr>
+        <p:style>
+          <a:lnRef idx="1">
+            <a:schemeClr val="accent1"/>
+          </a:lnRef>
+          <a:fillRef idx="3">
+            <a:schemeClr val="accent1"/>
+          </a:fillRef>
+          <a:effectRef idx="2">
+            <a:schemeClr val="accent1"/>
+          </a:effectRef>
+          <a:fontRef idx="minor">
+            <a:schemeClr val="lt1"/>
+          </a:fontRef>
+        </p:style>
+        <p:txBody>
+          <a:bodyPr rtlCol="0" anchor="ctr"/>
+          <a:lstStyle/>
+          <a:p>
+            <a:pPr algn="ctr"/>
+          </a:p>
+        </p:txBody>
+      </p:sp>
+      <p:sp>
+        <p:nvSpPr>
+          <p:cNvPr id="3" name="TextBox 2"/>
           <p:cNvSpPr txBox="1"/>
           <p:nvPr/>
         </p:nvSpPr>
         <p:spPr>
           <a:xfrm>
             <a:off x="685800" y="365760"/>
-            <a:ext cx="10789920" cy="914400"/>
+            <a:ext cx="10817352" cy="731520"/>
           </a:xfrm>
           <a:prstGeom prst="rect">
             <a:avLst/>
@@ -4290,7 +5075,7 @@
           <a:lstStyle/>
           <a:p>
             <a:pPr>
-              <a:defRPr sz="3600" b="1">
+              <a:defRPr sz="3200" b="1">
                 <a:solidFill>
                   <a:srgbClr val="102C57"/>
                 </a:solidFill>
@@ -4298,21 +5083,21 @@
               </a:defRPr>
             </a:pPr>
             <a:r>
-              <a:t>4) Domain &amp; Literature Survey (10 Papers)</a:t>
-            </a:r>
-          </a:p>
-        </p:txBody>
-      </p:sp>
-      <p:sp>
-        <p:nvSpPr>
-          <p:cNvPr id="3" name="Rectangle 2"/>
+              <a:t>4) Domain &amp; Literature Survey</a:t>
+            </a:r>
+          </a:p>
+        </p:txBody>
+      </p:sp>
+      <p:sp>
+        <p:nvSpPr>
+          <p:cNvPr id="4" name="Rectangle 3"/>
           <p:cNvSpPr/>
           <p:nvPr/>
         </p:nvSpPr>
         <p:spPr>
           <a:xfrm>
-            <a:off x="685800" y="1097280"/>
-            <a:ext cx="10817352" cy="36576"/>
+            <a:off x="685800" y="1051560"/>
+            <a:ext cx="1371600" cy="45720"/>
           </a:xfrm>
           <a:prstGeom prst="rect">
             <a:avLst/>
@@ -4348,318 +5133,710 @@
       </p:sp>
       <p:sp>
         <p:nvSpPr>
-          <p:cNvPr id="4" name="TextBox 3"/>
-          <p:cNvSpPr txBox="1"/>
+          <p:cNvPr id="5" name="Rounded Rectangle 4"/>
+          <p:cNvSpPr/>
           <p:nvPr/>
         </p:nvSpPr>
         <p:spPr>
           <a:xfrm>
-            <a:off x="685800" y="1371600"/>
-            <a:ext cx="5120640" cy="4937760"/>
-          </a:xfrm>
-          <a:prstGeom prst="rect">
+            <a:off x="685800" y="1463040"/>
+            <a:ext cx="2011680" cy="1828800"/>
+          </a:xfrm>
+          <a:prstGeom prst="roundRect">
             <a:avLst/>
           </a:prstGeom>
-          <a:noFill/>
-        </p:spPr>
-        <p:txBody>
-          <a:bodyPr wrap="square">
-            <a:spAutoFit/>
-          </a:bodyPr>
-          <a:lstStyle/>
-          <a:p/>
+          <a:solidFill>
+            <a:srgbClr val="FFFFFF"/>
+          </a:solidFill>
+          <a:ln w="12700">
+            <a:solidFill>
+              <a:srgbClr val="DAE0E9"/>
+            </a:solidFill>
+          </a:ln>
+        </p:spPr>
+        <p:style>
+          <a:lnRef idx="1">
+            <a:schemeClr val="accent1"/>
+          </a:lnRef>
+          <a:fillRef idx="3">
+            <a:schemeClr val="accent1"/>
+          </a:fillRef>
+          <a:effectRef idx="2">
+            <a:schemeClr val="accent1"/>
+          </a:effectRef>
+          <a:fontRef idx="minor">
+            <a:schemeClr val="lt1"/>
+          </a:fontRef>
+        </p:style>
+        <p:txBody>
+          <a:bodyPr rtlCol="0" anchor="ctr" wrap="square" lIns="137160" rIns="137160" tIns="137160"/>
+          <a:lstStyle/>
+          <a:p>
+            <a:pPr algn="ctr">
+              <a:spcAft>
+                <a:spcPts val="400"/>
+              </a:spcAft>
+              <a:defRPr sz="1200" b="1">
+                <a:solidFill>
+                  <a:srgbClr val="102C57"/>
+                </a:solidFill>
+                <a:latin typeface="Arial"/>
+              </a:defRPr>
+            </a:pPr>
+            <a:r>
+              <a:t>01. SVM Classifiers for Law</a:t>
+            </a:r>
+          </a:p>
           <a:p>
             <a:pPr>
-              <a:defRPr b="1" sz="1400">
-                <a:solidFill>
-                  <a:srgbClr val="102C57"/>
-                </a:solidFill>
+              <a:defRPr sz="950">
+                <a:solidFill>
+                  <a:srgbClr val="282828"/>
+                </a:solidFill>
+                <a:latin typeface="Arial"/>
               </a:defRPr>
             </a:pPr>
             <a:r>
-              <a:t>1. Judicial Decision Prediction via NLP</a:t>
-            </a:r>
-          </a:p>
-          <a:p>
-            <a:pPr>
-              <a:spcAft>
-                <a:spcPts val="800"/>
-              </a:spcAft>
-              <a:defRPr sz="1200">
-                <a:solidFill>
-                  <a:srgbClr val="323232"/>
-                </a:solidFill>
-              </a:defRPr>
-            </a:pPr>
-            <a:r>
-              <a:t>Explores SVM and Naive Bayes for outcome classification in commercial disputes.</a:t>
-            </a:r>
-          </a:p>
-          <a:p>
-            <a:pPr>
-              <a:defRPr b="1" sz="1400">
-                <a:solidFill>
-                  <a:srgbClr val="102C57"/>
-                </a:solidFill>
-              </a:defRPr>
-            </a:pPr>
-            <a:r>
-              <a:t>2. Semantic Case Retrieval Systems</a:t>
-            </a:r>
-          </a:p>
-          <a:p>
-            <a:pPr>
-              <a:spcAft>
-                <a:spcPts val="800"/>
-              </a:spcAft>
-              <a:defRPr sz="1200">
-                <a:solidFill>
-                  <a:srgbClr val="323232"/>
-                </a:solidFill>
-              </a:defRPr>
-            </a:pPr>
-            <a:r>
-              <a:t>Implements vector-space search and Cosine similarity for matching case facts.</a:t>
-            </a:r>
-          </a:p>
-          <a:p>
-            <a:pPr>
-              <a:defRPr b="1" sz="1400">
-                <a:solidFill>
-                  <a:srgbClr val="102C57"/>
-                </a:solidFill>
-              </a:defRPr>
-            </a:pPr>
-            <a:r>
-              <a:t>3. Indian Legal Text Digitalization</a:t>
-            </a:r>
-          </a:p>
-          <a:p>
-            <a:pPr>
-              <a:spcAft>
-                <a:spcPts val="800"/>
-              </a:spcAft>
-              <a:defRPr sz="1200">
-                <a:solidFill>
-                  <a:srgbClr val="323232"/>
-                </a:solidFill>
-              </a:defRPr>
-            </a:pPr>
-            <a:r>
-              <a:t>Studies structures of the National Judicial Data Grid (NJDG) and API endpoints.</a:t>
-            </a:r>
-          </a:p>
-          <a:p>
-            <a:pPr>
-              <a:defRPr b="1" sz="1400">
-                <a:solidFill>
-                  <a:srgbClr val="102C57"/>
-                </a:solidFill>
-              </a:defRPr>
-            </a:pPr>
-            <a:r>
-              <a:t>4. Named Entity Recognition in Law</a:t>
-            </a:r>
-          </a:p>
-          <a:p>
-            <a:pPr>
-              <a:spcAft>
-                <a:spcPts val="800"/>
-              </a:spcAft>
-              <a:defRPr sz="1200">
-                <a:solidFill>
-                  <a:srgbClr val="323232"/>
-                </a:solidFill>
-              </a:defRPr>
-            </a:pPr>
-            <a:r>
-              <a:t>Identifies entities (Judges, Lawyers, Statutes, and Sections) using rule-based parsing.</a:t>
-            </a:r>
-          </a:p>
-          <a:p>
-            <a:pPr>
-              <a:defRPr b="1" sz="1400">
-                <a:solidFill>
-                  <a:srgbClr val="102C57"/>
-                </a:solidFill>
-              </a:defRPr>
-            </a:pPr>
-            <a:r>
-              <a:t>5. Explainable AI (XAI) in Litigation</a:t>
-            </a:r>
-          </a:p>
-          <a:p>
-            <a:pPr>
-              <a:spcAft>
-                <a:spcPts val="800"/>
-              </a:spcAft>
-              <a:defRPr sz="1200">
-                <a:solidFill>
-                  <a:srgbClr val="323232"/>
-                </a:solidFill>
-              </a:defRPr>
-            </a:pPr>
-            <a:r>
-              <a:t>Focuses on providing transparent reasoning chains rather than black-box models.</a:t>
-            </a:r>
-          </a:p>
-        </p:txBody>
-      </p:sp>
-      <p:sp>
-        <p:nvSpPr>
-          <p:cNvPr id="5" name="TextBox 4"/>
-          <p:cNvSpPr txBox="1"/>
+              <a:t>Evaluates support vector machines in legal case categorization.</a:t>
+            </a:r>
+          </a:p>
+        </p:txBody>
+      </p:sp>
+      <p:sp>
+        <p:nvSpPr>
+          <p:cNvPr id="6" name="Rounded Rectangle 5"/>
+          <p:cNvSpPr/>
           <p:nvPr/>
         </p:nvSpPr>
         <p:spPr>
           <a:xfrm>
-            <a:off x="6309360" y="1371600"/>
-            <a:ext cx="5120640" cy="4937760"/>
-          </a:xfrm>
-          <a:prstGeom prst="rect">
+            <a:off x="2862072" y="1463040"/>
+            <a:ext cx="2011680" cy="1828800"/>
+          </a:xfrm>
+          <a:prstGeom prst="roundRect">
             <a:avLst/>
           </a:prstGeom>
-          <a:noFill/>
-        </p:spPr>
-        <p:txBody>
-          <a:bodyPr wrap="square">
-            <a:spAutoFit/>
-          </a:bodyPr>
-          <a:lstStyle/>
-          <a:p/>
+          <a:solidFill>
+            <a:srgbClr val="FFFFFF"/>
+          </a:solidFill>
+          <a:ln w="12700">
+            <a:solidFill>
+              <a:srgbClr val="DAE0E9"/>
+            </a:solidFill>
+          </a:ln>
+        </p:spPr>
+        <p:style>
+          <a:lnRef idx="1">
+            <a:schemeClr val="accent1"/>
+          </a:lnRef>
+          <a:fillRef idx="3">
+            <a:schemeClr val="accent1"/>
+          </a:fillRef>
+          <a:effectRef idx="2">
+            <a:schemeClr val="accent1"/>
+          </a:effectRef>
+          <a:fontRef idx="minor">
+            <a:schemeClr val="lt1"/>
+          </a:fontRef>
+        </p:style>
+        <p:txBody>
+          <a:bodyPr rtlCol="0" anchor="ctr" wrap="square" lIns="137160" rIns="137160" tIns="137160"/>
+          <a:lstStyle/>
+          <a:p>
+            <a:pPr algn="ctr">
+              <a:spcAft>
+                <a:spcPts val="400"/>
+              </a:spcAft>
+              <a:defRPr sz="1200" b="1">
+                <a:solidFill>
+                  <a:srgbClr val="102C57"/>
+                </a:solidFill>
+                <a:latin typeface="Arial"/>
+              </a:defRPr>
+            </a:pPr>
+            <a:r>
+              <a:t>02. Semantic Precedent Search</a:t>
+            </a:r>
+          </a:p>
           <a:p>
             <a:pPr>
-              <a:defRPr b="1" sz="1400">
+              <a:defRPr sz="950">
+                <a:solidFill>
+                  <a:srgbClr val="282828"/>
+                </a:solidFill>
+                <a:latin typeface="Arial"/>
+              </a:defRPr>
+            </a:pPr>
+            <a:r>
+              <a:t>Information retrieval models using cosine matching logic.</a:t>
+            </a:r>
+          </a:p>
+        </p:txBody>
+      </p:sp>
+      <p:sp>
+        <p:nvSpPr>
+          <p:cNvPr id="7" name="Rounded Rectangle 6"/>
+          <p:cNvSpPr/>
+          <p:nvPr/>
+        </p:nvSpPr>
+        <p:spPr>
+          <a:xfrm>
+            <a:off x="5038344" y="1463040"/>
+            <a:ext cx="2011680" cy="1828800"/>
+          </a:xfrm>
+          <a:prstGeom prst="roundRect">
+            <a:avLst/>
+          </a:prstGeom>
+          <a:solidFill>
+            <a:srgbClr val="FFFFFF"/>
+          </a:solidFill>
+          <a:ln w="12700">
+            <a:solidFill>
+              <a:srgbClr val="DAE0E9"/>
+            </a:solidFill>
+          </a:ln>
+        </p:spPr>
+        <p:style>
+          <a:lnRef idx="1">
+            <a:schemeClr val="accent1"/>
+          </a:lnRef>
+          <a:fillRef idx="3">
+            <a:schemeClr val="accent1"/>
+          </a:fillRef>
+          <a:effectRef idx="2">
+            <a:schemeClr val="accent1"/>
+          </a:effectRef>
+          <a:fontRef idx="minor">
+            <a:schemeClr val="lt1"/>
+          </a:fontRef>
+        </p:style>
+        <p:txBody>
+          <a:bodyPr rtlCol="0" anchor="ctr" wrap="square" lIns="137160" rIns="137160" tIns="137160"/>
+          <a:lstStyle/>
+          <a:p>
+            <a:pPr algn="ctr">
+              <a:spcAft>
+                <a:spcPts val="400"/>
+              </a:spcAft>
+              <a:defRPr sz="1200" b="1">
                 <a:solidFill>
                   <a:srgbClr val="102C57"/>
                 </a:solidFill>
+                <a:latin typeface="Arial"/>
               </a:defRPr>
             </a:pPr>
             <a:r>
-              <a:t>6. Statute Recommendation Engines</a:t>
+              <a:t>03. Legal NER Architectures</a:t>
             </a:r>
           </a:p>
           <a:p>
             <a:pPr>
+              <a:defRPr sz="950">
+                <a:solidFill>
+                  <a:srgbClr val="282828"/>
+                </a:solidFill>
+                <a:latin typeface="Arial"/>
+              </a:defRPr>
+            </a:pPr>
+            <a:r>
+              <a:t>Identifies sections, acts, and citations from judicial texts.</a:t>
+            </a:r>
+          </a:p>
+        </p:txBody>
+      </p:sp>
+      <p:sp>
+        <p:nvSpPr>
+          <p:cNvPr id="8" name="Rounded Rectangle 7"/>
+          <p:cNvSpPr/>
+          <p:nvPr/>
+        </p:nvSpPr>
+        <p:spPr>
+          <a:xfrm>
+            <a:off x="7214616" y="1463040"/>
+            <a:ext cx="2011680" cy="1828800"/>
+          </a:xfrm>
+          <a:prstGeom prst="roundRect">
+            <a:avLst/>
+          </a:prstGeom>
+          <a:solidFill>
+            <a:srgbClr val="FFFFFF"/>
+          </a:solidFill>
+          <a:ln w="12700">
+            <a:solidFill>
+              <a:srgbClr val="DAE0E9"/>
+            </a:solidFill>
+          </a:ln>
+        </p:spPr>
+        <p:style>
+          <a:lnRef idx="1">
+            <a:schemeClr val="accent1"/>
+          </a:lnRef>
+          <a:fillRef idx="3">
+            <a:schemeClr val="accent1"/>
+          </a:fillRef>
+          <a:effectRef idx="2">
+            <a:schemeClr val="accent1"/>
+          </a:effectRef>
+          <a:fontRef idx="minor">
+            <a:schemeClr val="lt1"/>
+          </a:fontRef>
+        </p:style>
+        <p:txBody>
+          <a:bodyPr rtlCol="0" anchor="ctr" wrap="square" lIns="137160" rIns="137160" tIns="137160"/>
+          <a:lstStyle/>
+          <a:p>
+            <a:pPr algn="ctr">
               <a:spcAft>
-                <a:spcPts val="800"/>
+                <a:spcPts val="400"/>
               </a:spcAft>
-              <a:defRPr sz="1200">
-                <a:solidFill>
-                  <a:srgbClr val="323232"/>
-                </a:solidFill>
+              <a:defRPr sz="1200" b="1">
+                <a:solidFill>
+                  <a:srgbClr val="102C57"/>
+                </a:solidFill>
+                <a:latin typeface="Arial"/>
               </a:defRPr>
             </a:pPr>
             <a:r>
-              <a:t>Matches natural language statements to legal provisions (IPC/BNS and CrPC).</a:t>
+              <a:t>04. Digitization in Judiciary</a:t>
             </a:r>
           </a:p>
           <a:p>
             <a:pPr>
-              <a:defRPr b="1" sz="1400">
+              <a:defRPr sz="950">
+                <a:solidFill>
+                  <a:srgbClr val="282828"/>
+                </a:solidFill>
+                <a:latin typeface="Arial"/>
+              </a:defRPr>
+            </a:pPr>
+            <a:r>
+              <a:t>Analyzes the framework structure of the Indian NJDG.</a:t>
+            </a:r>
+          </a:p>
+        </p:txBody>
+      </p:sp>
+      <p:sp>
+        <p:nvSpPr>
+          <p:cNvPr id="9" name="Rounded Rectangle 8"/>
+          <p:cNvSpPr/>
+          <p:nvPr/>
+        </p:nvSpPr>
+        <p:spPr>
+          <a:xfrm>
+            <a:off x="9390888" y="1463040"/>
+            <a:ext cx="2011680" cy="1828800"/>
+          </a:xfrm>
+          <a:prstGeom prst="roundRect">
+            <a:avLst/>
+          </a:prstGeom>
+          <a:solidFill>
+            <a:srgbClr val="FFFFFF"/>
+          </a:solidFill>
+          <a:ln w="12700">
+            <a:solidFill>
+              <a:srgbClr val="DAE0E9"/>
+            </a:solidFill>
+          </a:ln>
+        </p:spPr>
+        <p:style>
+          <a:lnRef idx="1">
+            <a:schemeClr val="accent1"/>
+          </a:lnRef>
+          <a:fillRef idx="3">
+            <a:schemeClr val="accent1"/>
+          </a:fillRef>
+          <a:effectRef idx="2">
+            <a:schemeClr val="accent1"/>
+          </a:effectRef>
+          <a:fontRef idx="minor">
+            <a:schemeClr val="lt1"/>
+          </a:fontRef>
+        </p:style>
+        <p:txBody>
+          <a:bodyPr rtlCol="0" anchor="ctr" wrap="square" lIns="137160" rIns="137160" tIns="137160"/>
+          <a:lstStyle/>
+          <a:p>
+            <a:pPr algn="ctr">
+              <a:spcAft>
+                <a:spcPts val="400"/>
+              </a:spcAft>
+              <a:defRPr sz="1200" b="1">
                 <a:solidFill>
                   <a:srgbClr val="102C57"/>
                 </a:solidFill>
+                <a:latin typeface="Arial"/>
               </a:defRPr>
             </a:pPr>
             <a:r>
-              <a:t>7. Vector Indexing for Precedents</a:t>
+              <a:t>05. Explainable AI (XAI)</a:t>
             </a:r>
           </a:p>
           <a:p>
             <a:pPr>
+              <a:defRPr sz="950">
+                <a:solidFill>
+                  <a:srgbClr val="282828"/>
+                </a:solidFill>
+                <a:latin typeface="Arial"/>
+              </a:defRPr>
+            </a:pPr>
+            <a:r>
+              <a:t>Discusses visual representation of logical chains in decisions.</a:t>
+            </a:r>
+          </a:p>
+        </p:txBody>
+      </p:sp>
+      <p:sp>
+        <p:nvSpPr>
+          <p:cNvPr id="10" name="Rounded Rectangle 9"/>
+          <p:cNvSpPr/>
+          <p:nvPr/>
+        </p:nvSpPr>
+        <p:spPr>
+          <a:xfrm>
+            <a:off x="685800" y="3474720"/>
+            <a:ext cx="2011680" cy="1828800"/>
+          </a:xfrm>
+          <a:prstGeom prst="roundRect">
+            <a:avLst/>
+          </a:prstGeom>
+          <a:solidFill>
+            <a:srgbClr val="FFFFFF"/>
+          </a:solidFill>
+          <a:ln w="12700">
+            <a:solidFill>
+              <a:srgbClr val="DAE0E9"/>
+            </a:solidFill>
+          </a:ln>
+        </p:spPr>
+        <p:style>
+          <a:lnRef idx="1">
+            <a:schemeClr val="accent1"/>
+          </a:lnRef>
+          <a:fillRef idx="3">
+            <a:schemeClr val="accent1"/>
+          </a:fillRef>
+          <a:effectRef idx="2">
+            <a:schemeClr val="accent1"/>
+          </a:effectRef>
+          <a:fontRef idx="minor">
+            <a:schemeClr val="lt1"/>
+          </a:fontRef>
+        </p:style>
+        <p:txBody>
+          <a:bodyPr rtlCol="0" anchor="ctr" wrap="square" lIns="137160" rIns="137160" tIns="137160"/>
+          <a:lstStyle/>
+          <a:p>
+            <a:pPr algn="ctr">
               <a:spcAft>
-                <a:spcPts val="800"/>
+                <a:spcPts val="400"/>
               </a:spcAft>
-              <a:defRPr sz="1200">
-                <a:solidFill>
-                  <a:srgbClr val="323232"/>
-                </a:solidFill>
+              <a:defRPr sz="1200" b="1">
+                <a:solidFill>
+                  <a:srgbClr val="102C57"/>
+                </a:solidFill>
+                <a:latin typeface="Arial"/>
               </a:defRPr>
             </a:pPr>
             <a:r>
-              <a:t>Analyzes performance of high-dimensional case vector databases.</a:t>
+              <a:t>06. Recommendation Engines</a:t>
             </a:r>
           </a:p>
           <a:p>
             <a:pPr>
-              <a:defRPr b="1" sz="1400">
+              <a:defRPr sz="950">
+                <a:solidFill>
+                  <a:srgbClr val="282828"/>
+                </a:solidFill>
+                <a:latin typeface="Arial"/>
+              </a:defRPr>
+            </a:pPr>
+            <a:r>
+              <a:t>Dynamic mapping systems correlating facts to specific statutes.</a:t>
+            </a:r>
+          </a:p>
+        </p:txBody>
+      </p:sp>
+      <p:sp>
+        <p:nvSpPr>
+          <p:cNvPr id="11" name="Rounded Rectangle 10"/>
+          <p:cNvSpPr/>
+          <p:nvPr/>
+        </p:nvSpPr>
+        <p:spPr>
+          <a:xfrm>
+            <a:off x="2862072" y="3474720"/>
+            <a:ext cx="2011680" cy="1828800"/>
+          </a:xfrm>
+          <a:prstGeom prst="roundRect">
+            <a:avLst/>
+          </a:prstGeom>
+          <a:solidFill>
+            <a:srgbClr val="FFFFFF"/>
+          </a:solidFill>
+          <a:ln w="12700">
+            <a:solidFill>
+              <a:srgbClr val="DAE0E9"/>
+            </a:solidFill>
+          </a:ln>
+        </p:spPr>
+        <p:style>
+          <a:lnRef idx="1">
+            <a:schemeClr val="accent1"/>
+          </a:lnRef>
+          <a:fillRef idx="3">
+            <a:schemeClr val="accent1"/>
+          </a:fillRef>
+          <a:effectRef idx="2">
+            <a:schemeClr val="accent1"/>
+          </a:effectRef>
+          <a:fontRef idx="minor">
+            <a:schemeClr val="lt1"/>
+          </a:fontRef>
+        </p:style>
+        <p:txBody>
+          <a:bodyPr rtlCol="0" anchor="ctr" wrap="square" lIns="137160" rIns="137160" tIns="137160"/>
+          <a:lstStyle/>
+          <a:p>
+            <a:pPr algn="ctr">
+              <a:spcAft>
+                <a:spcPts val="400"/>
+              </a:spcAft>
+              <a:defRPr sz="1200" b="1">
                 <a:solidFill>
                   <a:srgbClr val="102C57"/>
                 </a:solidFill>
+                <a:latin typeface="Arial"/>
               </a:defRPr>
             </a:pPr>
             <a:r>
-              <a:t>8. Factual Simulation in Lawsuits</a:t>
+              <a:t>07. Vector Space Indexes</a:t>
             </a:r>
           </a:p>
           <a:p>
             <a:pPr>
+              <a:defRPr sz="950">
+                <a:solidFill>
+                  <a:srgbClr val="282828"/>
+                </a:solidFill>
+                <a:latin typeface="Arial"/>
+              </a:defRPr>
+            </a:pPr>
+            <a:r>
+              <a:t>Analyzes vector database latency during large precedent requests.</a:t>
+            </a:r>
+          </a:p>
+        </p:txBody>
+      </p:sp>
+      <p:sp>
+        <p:nvSpPr>
+          <p:cNvPr id="12" name="Rounded Rectangle 11"/>
+          <p:cNvSpPr/>
+          <p:nvPr/>
+        </p:nvSpPr>
+        <p:spPr>
+          <a:xfrm>
+            <a:off x="5038344" y="3474720"/>
+            <a:ext cx="2011680" cy="1828800"/>
+          </a:xfrm>
+          <a:prstGeom prst="roundRect">
+            <a:avLst/>
+          </a:prstGeom>
+          <a:solidFill>
+            <a:srgbClr val="FFFFFF"/>
+          </a:solidFill>
+          <a:ln w="12700">
+            <a:solidFill>
+              <a:srgbClr val="DAE0E9"/>
+            </a:solidFill>
+          </a:ln>
+        </p:spPr>
+        <p:style>
+          <a:lnRef idx="1">
+            <a:schemeClr val="accent1"/>
+          </a:lnRef>
+          <a:fillRef idx="3">
+            <a:schemeClr val="accent1"/>
+          </a:fillRef>
+          <a:effectRef idx="2">
+            <a:schemeClr val="accent1"/>
+          </a:effectRef>
+          <a:fontRef idx="minor">
+            <a:schemeClr val="lt1"/>
+          </a:fontRef>
+        </p:style>
+        <p:txBody>
+          <a:bodyPr rtlCol="0" anchor="ctr" wrap="square" lIns="137160" rIns="137160" tIns="137160"/>
+          <a:lstStyle/>
+          <a:p>
+            <a:pPr algn="ctr">
               <a:spcAft>
-                <a:spcPts val="800"/>
+                <a:spcPts val="400"/>
               </a:spcAft>
-              <a:defRPr sz="1200">
-                <a:solidFill>
-                  <a:srgbClr val="323232"/>
-                </a:solidFill>
+              <a:defRPr sz="1200" b="1">
+                <a:solidFill>
+                  <a:srgbClr val="102C57"/>
+                </a:solidFill>
+                <a:latin typeface="Arial"/>
               </a:defRPr>
             </a:pPr>
             <a:r>
-              <a:t>Models counterfactual arguments and their influence on final judicial outputs.</a:t>
+              <a:t>08. Counterfactual Simulators</a:t>
             </a:r>
           </a:p>
           <a:p>
             <a:pPr>
-              <a:defRPr b="1" sz="1400">
+              <a:defRPr sz="950">
+                <a:solidFill>
+                  <a:srgbClr val="282828"/>
+                </a:solidFill>
+                <a:latin typeface="Arial"/>
+              </a:defRPr>
+            </a:pPr>
+            <a:r>
+              <a:t>Evaluates causal graph dependencies in judicial arguments.</a:t>
+            </a:r>
+          </a:p>
+        </p:txBody>
+      </p:sp>
+      <p:sp>
+        <p:nvSpPr>
+          <p:cNvPr id="13" name="Rounded Rectangle 12"/>
+          <p:cNvSpPr/>
+          <p:nvPr/>
+        </p:nvSpPr>
+        <p:spPr>
+          <a:xfrm>
+            <a:off x="7214616" y="3474720"/>
+            <a:ext cx="2011680" cy="1828800"/>
+          </a:xfrm>
+          <a:prstGeom prst="roundRect">
+            <a:avLst/>
+          </a:prstGeom>
+          <a:solidFill>
+            <a:srgbClr val="FFFFFF"/>
+          </a:solidFill>
+          <a:ln w="12700">
+            <a:solidFill>
+              <a:srgbClr val="DAE0E9"/>
+            </a:solidFill>
+          </a:ln>
+        </p:spPr>
+        <p:style>
+          <a:lnRef idx="1">
+            <a:schemeClr val="accent1"/>
+          </a:lnRef>
+          <a:fillRef idx="3">
+            <a:schemeClr val="accent1"/>
+          </a:fillRef>
+          <a:effectRef idx="2">
+            <a:schemeClr val="accent1"/>
+          </a:effectRef>
+          <a:fontRef idx="minor">
+            <a:schemeClr val="lt1"/>
+          </a:fontRef>
+        </p:style>
+        <p:txBody>
+          <a:bodyPr rtlCol="0" anchor="ctr" wrap="square" lIns="137160" rIns="137160" tIns="137160"/>
+          <a:lstStyle/>
+          <a:p>
+            <a:pPr algn="ctr">
+              <a:spcAft>
+                <a:spcPts val="400"/>
+              </a:spcAft>
+              <a:defRPr sz="1200" b="1">
                 <a:solidFill>
                   <a:srgbClr val="102C57"/>
                 </a:solidFill>
+                <a:latin typeface="Arial"/>
               </a:defRPr>
             </a:pPr>
             <a:r>
-              <a:t>9. Legal Chatbots using RAG</a:t>
+              <a:t>09. Legal Question-Answering</a:t>
             </a:r>
           </a:p>
           <a:p>
             <a:pPr>
+              <a:defRPr sz="950">
+                <a:solidFill>
+                  <a:srgbClr val="282828"/>
+                </a:solidFill>
+                <a:latin typeface="Arial"/>
+              </a:defRPr>
+            </a:pPr>
+            <a:r>
+              <a:t>Leverages RAG pipelines for secure legal knowledge lookup.</a:t>
+            </a:r>
+          </a:p>
+        </p:txBody>
+      </p:sp>
+      <p:sp>
+        <p:nvSpPr>
+          <p:cNvPr id="14" name="Rounded Rectangle 13"/>
+          <p:cNvSpPr/>
+          <p:nvPr/>
+        </p:nvSpPr>
+        <p:spPr>
+          <a:xfrm>
+            <a:off x="9390888" y="3474720"/>
+            <a:ext cx="2011680" cy="1828800"/>
+          </a:xfrm>
+          <a:prstGeom prst="roundRect">
+            <a:avLst/>
+          </a:prstGeom>
+          <a:solidFill>
+            <a:srgbClr val="FFFFFF"/>
+          </a:solidFill>
+          <a:ln w="12700">
+            <a:solidFill>
+              <a:srgbClr val="DAE0E9"/>
+            </a:solidFill>
+          </a:ln>
+        </p:spPr>
+        <p:style>
+          <a:lnRef idx="1">
+            <a:schemeClr val="accent1"/>
+          </a:lnRef>
+          <a:fillRef idx="3">
+            <a:schemeClr val="accent1"/>
+          </a:fillRef>
+          <a:effectRef idx="2">
+            <a:schemeClr val="accent1"/>
+          </a:effectRef>
+          <a:fontRef idx="minor">
+            <a:schemeClr val="lt1"/>
+          </a:fontRef>
+        </p:style>
+        <p:txBody>
+          <a:bodyPr rtlCol="0" anchor="ctr" wrap="square" lIns="137160" rIns="137160" tIns="137160"/>
+          <a:lstStyle/>
+          <a:p>
+            <a:pPr algn="ctr">
               <a:spcAft>
-                <a:spcPts val="800"/>
+                <a:spcPts val="400"/>
               </a:spcAft>
-              <a:defRPr sz="1200">
-                <a:solidFill>
-                  <a:srgbClr val="323232"/>
-                </a:solidFill>
+              <a:defRPr sz="1200" b="1">
+                <a:solidFill>
+                  <a:srgbClr val="102C57"/>
+                </a:solidFill>
+                <a:latin typeface="Arial"/>
               </a:defRPr>
             </a:pPr>
             <a:r>
-              <a:t>Combines verified legal codices with NLP to provide factual, secure chat answers.</a:t>
+              <a:t>10. Sentiment &amp; Keyword Weights</a:t>
             </a:r>
           </a:p>
           <a:p>
             <a:pPr>
-              <a:defRPr b="1" sz="1400">
-                <a:solidFill>
-                  <a:srgbClr val="102C57"/>
-                </a:solidFill>
+              <a:defRPr sz="950">
+                <a:solidFill>
+                  <a:srgbClr val="282828"/>
+                </a:solidFill>
+                <a:latin typeface="Arial"/>
               </a:defRPr>
             </a:pPr>
             <a:r>
-              <a:t>10. Sentiment Analysis in Judicial Text</a:t>
-            </a:r>
-          </a:p>
-          <a:p>
-            <a:pPr>
-              <a:spcAft>
-                <a:spcPts val="800"/>
-              </a:spcAft>
-              <a:defRPr sz="1200">
-                <a:solidFill>
-                  <a:srgbClr val="323232"/>
-                </a:solidFill>
-              </a:defRPr>
-            </a:pPr>
-            <a:r>
-              <a:t>Evaluates tone, keywords, and semantic structure of written judgment summaries.</a:t>
+              <a:t>Extracts keyword frequencies to categorize court verdicts.</a:t>
             </a:r>
           </a:p>
         </p:txBody>
@@ -4684,14 +5861,57 @@
       <p:grpSpPr/>
       <p:sp>
         <p:nvSpPr>
-          <p:cNvPr id="2" name="TextBox 1"/>
+          <p:cNvPr id="2" name="Rectangle 1"/>
+          <p:cNvSpPr/>
+          <p:nvPr/>
+        </p:nvSpPr>
+        <p:spPr>
+          <a:xfrm>
+            <a:off x="0" y="0"/>
+            <a:ext cx="12191695" cy="6858000"/>
+          </a:xfrm>
+          <a:prstGeom prst="rect">
+            <a:avLst/>
+          </a:prstGeom>
+          <a:solidFill>
+            <a:srgbClr val="F5F7FA"/>
+          </a:solidFill>
+          <a:ln>
+            <a:noFill/>
+          </a:ln>
+        </p:spPr>
+        <p:style>
+          <a:lnRef idx="1">
+            <a:schemeClr val="accent1"/>
+          </a:lnRef>
+          <a:fillRef idx="3">
+            <a:schemeClr val="accent1"/>
+          </a:fillRef>
+          <a:effectRef idx="2">
+            <a:schemeClr val="accent1"/>
+          </a:effectRef>
+          <a:fontRef idx="minor">
+            <a:schemeClr val="lt1"/>
+          </a:fontRef>
+        </p:style>
+        <p:txBody>
+          <a:bodyPr rtlCol="0" anchor="ctr"/>
+          <a:lstStyle/>
+          <a:p>
+            <a:pPr algn="ctr"/>
+          </a:p>
+        </p:txBody>
+      </p:sp>
+      <p:sp>
+        <p:nvSpPr>
+          <p:cNvPr id="3" name="TextBox 2"/>
           <p:cNvSpPr txBox="1"/>
           <p:nvPr/>
         </p:nvSpPr>
         <p:spPr>
           <a:xfrm>
             <a:off x="685800" y="365760"/>
-            <a:ext cx="10789920" cy="914400"/>
+            <a:ext cx="10817352" cy="731520"/>
           </a:xfrm>
           <a:prstGeom prst="rect">
             <a:avLst/>
@@ -4705,7 +5925,7 @@
           <a:lstStyle/>
           <a:p>
             <a:pPr>
-              <a:defRPr sz="3600" b="1">
+              <a:defRPr sz="3200" b="1">
                 <a:solidFill>
                   <a:srgbClr val="102C57"/>
                 </a:solidFill>
@@ -4720,14 +5940,14 @@
       </p:sp>
       <p:sp>
         <p:nvSpPr>
-          <p:cNvPr id="3" name="Rectangle 2"/>
+          <p:cNvPr id="4" name="Rectangle 3"/>
           <p:cNvSpPr/>
           <p:nvPr/>
         </p:nvSpPr>
         <p:spPr>
           <a:xfrm>
-            <a:off x="685800" y="1097280"/>
-            <a:ext cx="10817352" cy="36576"/>
+            <a:off x="685800" y="1051560"/>
+            <a:ext cx="1371600" cy="45720"/>
           </a:xfrm>
           <a:prstGeom prst="rect">
             <a:avLst/>
@@ -4763,7 +5983,7 @@
       </p:sp>
       <p:graphicFrame>
         <p:nvGraphicFramePr>
-          <p:cNvPr id="4" name="Table 3"/>
+          <p:cNvPr id="5" name="Table 4"/>
           <p:cNvGraphicFramePr>
             <a:graphicFrameLocks noGrp="1"/>
           </p:cNvGraphicFramePr>
@@ -4771,7 +5991,7 @@
         </p:nvGraphicFramePr>
         <p:xfrm>
           <a:off x="685800" y="1645920"/>
-          <a:ext cx="10817352" cy="4114800"/>
+          <a:ext cx="10817352" cy="4206240"/>
         </p:xfrm>
         <a:graphic>
           <a:graphicData uri="http://schemas.openxmlformats.org/drawingml/2006/table">
@@ -4780,19 +6000,19 @@
                 <a:tableStyleId>{5C22544A-7EE6-4342-B048-85BDC9FD1C3A}</a:tableStyleId>
               </a:tblPr>
               <a:tblGrid>
-                <a:gridCol w="2039112"/>
+                <a:gridCol w="2011680"/>
                 <a:gridCol w="2926080"/>
                 <a:gridCol w="2926080"/>
-                <a:gridCol w="2926080"/>
+                <a:gridCol w="2953512"/>
               </a:tblGrid>
-              <a:tr h="1028700">
+              <a:tr h="1051560">
                 <a:tc>
                   <a:txBody>
                     <a:bodyPr/>
                     <a:lstStyle/>
                     <a:p>
                       <a:pPr algn="ctr">
-                        <a:defRPr b="1" sz="1400">
+                        <a:defRPr b="1" sz="1300">
                           <a:solidFill>
                             <a:srgbClr val="FFFFFF"/>
                           </a:solidFill>
@@ -4815,7 +6035,7 @@
                     <a:lstStyle/>
                     <a:p>
                       <a:pPr algn="ctr">
-                        <a:defRPr b="1" sz="1400">
+                        <a:defRPr b="1" sz="1300">
                           <a:solidFill>
                             <a:srgbClr val="FFFFFF"/>
                           </a:solidFill>
@@ -4838,7 +6058,7 @@
                     <a:lstStyle/>
                     <a:p>
                       <a:pPr algn="ctr">
-                        <a:defRPr b="1" sz="1400">
+                        <a:defRPr b="1" sz="1300">
                           <a:solidFill>
                             <a:srgbClr val="FFFFFF"/>
                           </a:solidFill>
@@ -4861,7 +6081,7 @@
                     <a:lstStyle/>
                     <a:p>
                       <a:pPr algn="ctr">
-                        <a:defRPr b="1" sz="1400">
+                        <a:defRPr b="1" sz="1300">
                           <a:solidFill>
                             <a:srgbClr val="FFFFFF"/>
                           </a:solidFill>
@@ -4879,21 +6099,21 @@
                   </a:tcPr>
                 </a:tc>
               </a:tr>
-              <a:tr h="1028700">
+              <a:tr h="1051560">
                 <a:tc>
                   <a:txBody>
                     <a:bodyPr/>
                     <a:lstStyle/>
                     <a:p>
                       <a:pPr>
-                        <a:defRPr sz="1200" b="1">
+                        <a:defRPr sz="1100" b="1">
                           <a:solidFill>
                             <a:srgbClr val="102C57"/>
                           </a:solidFill>
                         </a:defRPr>
                       </a:pPr>
                       <a:r>
-                        <a:t>Search Methodology</a:t>
+                        <a:t>Search Logic</a:t>
                       </a:r>
                     </a:p>
                   </a:txBody>
@@ -4909,14 +6129,14 @@
                     <a:lstStyle/>
                     <a:p>
                       <a:pPr>
-                        <a:defRPr sz="1200">
+                        <a:defRPr sz="1100">
                           <a:solidFill>
-                            <a:srgbClr val="323232"/>
+                            <a:srgbClr val="282828"/>
                           </a:solidFill>
                         </a:defRPr>
                       </a:pPr>
                       <a:r>
-                        <a:t>Strictly keyword-based searches; requires exact query matches.</a:t>
+                        <a:t>Strictly keyword matches; requires exact strings.</a:t>
                       </a:r>
                     </a:p>
                   </a:txBody>
@@ -4932,14 +6152,14 @@
                     <a:lstStyle/>
                     <a:p>
                       <a:pPr>
-                        <a:defRPr sz="1200">
+                        <a:defRPr sz="1100">
                           <a:solidFill>
-                            <a:srgbClr val="323232"/>
+                            <a:srgbClr val="282828"/>
                           </a:solidFill>
                         </a:defRPr>
                       </a:pPr>
                       <a:r>
-                        <a:t>Basic Natural Language Search inputs.</a:t>
+                        <a:t>Basic NLP inputs.</a:t>
                       </a:r>
                     </a:p>
                   </a:txBody>
@@ -4955,14 +6175,14 @@
                     <a:lstStyle/>
                     <a:p>
                       <a:pPr>
-                        <a:defRPr sz="1200" b="1">
+                        <a:defRPr sz="1100" b="1">
                           <a:solidFill>
-                            <a:srgbClr val="323232"/>
+                            <a:srgbClr val="282828"/>
                           </a:solidFill>
                         </a:defRPr>
                       </a:pPr>
                       <a:r>
-                        <a:t>Deep semantic retrieval (TF-IDF &amp; Cosine Similarity search).</a:t>
+                        <a:t>Deep semantic retrieval via Cosine Similarity (TF-IDF vector weights).</a:t>
                       </a:r>
                     </a:p>
                   </a:txBody>
@@ -4973,21 +6193,21 @@
                   </a:tcPr>
                 </a:tc>
               </a:tr>
-              <a:tr h="1028700">
+              <a:tr h="1051560">
                 <a:tc>
                   <a:txBody>
                     <a:bodyPr/>
                     <a:lstStyle/>
                     <a:p>
                       <a:pPr>
-                        <a:defRPr sz="1200" b="1">
+                        <a:defRPr sz="1100" b="1">
                           <a:solidFill>
                             <a:srgbClr val="102C57"/>
                           </a:solidFill>
                         </a:defRPr>
                       </a:pPr>
                       <a:r>
-                        <a:t>Prediction Capacity</a:t>
+                        <a:t>Predictive Capability</a:t>
                       </a:r>
                     </a:p>
                   </a:txBody>
@@ -5003,14 +6223,14 @@
                     <a:lstStyle/>
                     <a:p>
                       <a:pPr>
-                        <a:defRPr sz="1200">
+                        <a:defRPr sz="1100">
                           <a:solidFill>
-                            <a:srgbClr val="323232"/>
+                            <a:srgbClr val="282828"/>
                           </a:solidFill>
                         </a:defRPr>
                       </a:pPr>
                       <a:r>
-                        <a:t>None. Provides database directory index lists only.</a:t>
+                        <a:t>None. Act solely as database directories.</a:t>
                       </a:r>
                     </a:p>
                   </a:txBody>
@@ -5026,14 +6246,14 @@
                     <a:lstStyle/>
                     <a:p>
                       <a:pPr>
-                        <a:defRPr sz="1200">
+                        <a:defRPr sz="1100">
                           <a:solidFill>
-                            <a:srgbClr val="323232"/>
+                            <a:srgbClr val="282828"/>
                           </a:solidFill>
                         </a:defRPr>
                       </a:pPr>
                       <a:r>
-                        <a:t>Basic analytics percentages without citations.</a:t>
+                        <a:t>Basic statistics without citation links.</a:t>
                       </a:r>
                     </a:p>
                   </a:txBody>
@@ -5049,14 +6269,14 @@
                     <a:lstStyle/>
                     <a:p>
                       <a:pPr>
-                        <a:defRPr sz="1200" b="1">
+                        <a:defRPr sz="1100" b="1">
                           <a:solidFill>
-                            <a:srgbClr val="323232"/>
+                            <a:srgbClr val="282828"/>
                           </a:solidFill>
                         </a:defRPr>
                       </a:pPr>
                       <a:r>
-                        <a:t>Evidence-based outcome prediction with confidence scores &amp; citations.</a:t>
+                        <a:t>Explainable prediction output with confidence scores &amp; precedent citations.</a:t>
                       </a:r>
                     </a:p>
                   </a:txBody>
@@ -5067,21 +6287,21 @@
                   </a:tcPr>
                 </a:tc>
               </a:tr>
-              <a:tr h="1028700">
+              <a:tr h="1051560">
                 <a:tc>
                   <a:txBody>
                     <a:bodyPr/>
                     <a:lstStyle/>
                     <a:p>
                       <a:pPr>
-                        <a:defRPr sz="1200" b="1">
+                        <a:defRPr sz="1100" b="1">
                           <a:solidFill>
                             <a:srgbClr val="102C57"/>
                           </a:solidFill>
                         </a:defRPr>
                       </a:pPr>
                       <a:r>
-                        <a:t>What-If Fact Simulation</a:t>
+                        <a:t>What-If Fact Testing</a:t>
                       </a:r>
                     </a:p>
                   </a:txBody>
@@ -5097,9 +6317,9 @@
                     <a:lstStyle/>
                     <a:p>
                       <a:pPr>
-                        <a:defRPr sz="1200">
+                        <a:defRPr sz="1100">
                           <a:solidFill>
-                            <a:srgbClr val="323232"/>
+                            <a:srgbClr val="282828"/>
                           </a:solidFill>
                         </a:defRPr>
                       </a:pPr>
@@ -5120,9 +6340,9 @@
                     <a:lstStyle/>
                     <a:p>
                       <a:pPr>
-                        <a:defRPr sz="1200">
+                        <a:defRPr sz="1100">
                           <a:solidFill>
-                            <a:srgbClr val="323232"/>
+                            <a:srgbClr val="282828"/>
                           </a:solidFill>
                         </a:defRPr>
                       </a:pPr>
@@ -5143,14 +6363,14 @@
                     <a:lstStyle/>
                     <a:p>
                       <a:pPr>
-                        <a:defRPr sz="1200" b="1">
+                        <a:defRPr sz="1100" b="1">
                           <a:solidFill>
-                            <a:srgbClr val="323232"/>
+                            <a:srgbClr val="282828"/>
                           </a:solidFill>
                         </a:defRPr>
                       </a:pPr>
                       <a:r>
-                        <a:t>Interactive Fact &amp; Evidence strength simulator with real-time recalculations.</a:t>
+                        <a:t>Interactive Fact &amp; Evidence strength simulator with instant cloud updates.</a:t>
                       </a:r>
                     </a:p>
                   </a:txBody>

</xml_diff>